<commit_message>
feat: implement spice for some circuits batchA
</commit_message>
<xml_diff>
--- a/notes/third_part_from_json_to_spice/presentazione_integrazione_json_spice_diagnosi_ai.pptx
+++ b/notes/third_part_from_json_to_spice/presentazione_integrazione_json_spice_diagnosi_ai.pptx
@@ -331,7 +331,7 @@
           <a:p>
             <a:fld id="{5BCAD085-E8A6-8845-BD4E-CB4CCA059FC4}" type="datetimeFigureOut">
               <a:rPr lang="en-US" smtClean="0"/>
-              <a:t>6/10/2026</a:t>
+              <a:t>6/15/2026</a:t>
             </a:fld>
             <a:endParaRPr lang="en-US"/>
           </a:p>
@@ -499,7 +499,7 @@
           <a:p>
             <a:fld id="{5BCAD085-E8A6-8845-BD4E-CB4CCA059FC4}" type="datetimeFigureOut">
               <a:rPr lang="en-US" smtClean="0"/>
-              <a:t>6/10/2026</a:t>
+              <a:t>6/15/2026</a:t>
             </a:fld>
             <a:endParaRPr lang="en-US"/>
           </a:p>
@@ -677,7 +677,7 @@
           <a:p>
             <a:fld id="{5BCAD085-E8A6-8845-BD4E-CB4CCA059FC4}" type="datetimeFigureOut">
               <a:rPr lang="en-US" smtClean="0"/>
-              <a:t>6/10/2026</a:t>
+              <a:t>6/15/2026</a:t>
             </a:fld>
             <a:endParaRPr lang="en-US"/>
           </a:p>
@@ -845,7 +845,7 @@
           <a:p>
             <a:fld id="{5BCAD085-E8A6-8845-BD4E-CB4CCA059FC4}" type="datetimeFigureOut">
               <a:rPr lang="en-US" smtClean="0"/>
-              <a:t>6/10/2026</a:t>
+              <a:t>6/15/2026</a:t>
             </a:fld>
             <a:endParaRPr lang="en-US"/>
           </a:p>
@@ -1090,7 +1090,7 @@
           <a:p>
             <a:fld id="{5BCAD085-E8A6-8845-BD4E-CB4CCA059FC4}" type="datetimeFigureOut">
               <a:rPr lang="en-US" smtClean="0"/>
-              <a:t>6/10/2026</a:t>
+              <a:t>6/15/2026</a:t>
             </a:fld>
             <a:endParaRPr lang="en-US"/>
           </a:p>
@@ -1375,7 +1375,7 @@
           <a:p>
             <a:fld id="{5BCAD085-E8A6-8845-BD4E-CB4CCA059FC4}" type="datetimeFigureOut">
               <a:rPr lang="en-US" smtClean="0"/>
-              <a:t>6/10/2026</a:t>
+              <a:t>6/15/2026</a:t>
             </a:fld>
             <a:endParaRPr lang="en-US"/>
           </a:p>
@@ -1794,7 +1794,7 @@
           <a:p>
             <a:fld id="{5BCAD085-E8A6-8845-BD4E-CB4CCA059FC4}" type="datetimeFigureOut">
               <a:rPr lang="en-US" smtClean="0"/>
-              <a:t>6/10/2026</a:t>
+              <a:t>6/15/2026</a:t>
             </a:fld>
             <a:endParaRPr lang="en-US"/>
           </a:p>
@@ -1911,7 +1911,7 @@
           <a:p>
             <a:fld id="{5BCAD085-E8A6-8845-BD4E-CB4CCA059FC4}" type="datetimeFigureOut">
               <a:rPr lang="en-US" smtClean="0"/>
-              <a:t>6/10/2026</a:t>
+              <a:t>6/15/2026</a:t>
             </a:fld>
             <a:endParaRPr lang="en-US"/>
           </a:p>
@@ -2006,7 +2006,7 @@
           <a:p>
             <a:fld id="{5BCAD085-E8A6-8845-BD4E-CB4CCA059FC4}" type="datetimeFigureOut">
               <a:rPr lang="en-US" smtClean="0"/>
-              <a:t>6/10/2026</a:t>
+              <a:t>6/15/2026</a:t>
             </a:fld>
             <a:endParaRPr lang="en-US"/>
           </a:p>
@@ -2281,7 +2281,7 @@
           <a:p>
             <a:fld id="{5BCAD085-E8A6-8845-BD4E-CB4CCA059FC4}" type="datetimeFigureOut">
               <a:rPr lang="en-US" smtClean="0"/>
-              <a:t>6/10/2026</a:t>
+              <a:t>6/15/2026</a:t>
             </a:fld>
             <a:endParaRPr lang="en-US"/>
           </a:p>
@@ -2533,7 +2533,7 @@
           <a:p>
             <a:fld id="{5BCAD085-E8A6-8845-BD4E-CB4CCA059FC4}" type="datetimeFigureOut">
               <a:rPr lang="en-US" smtClean="0"/>
-              <a:t>6/10/2026</a:t>
+              <a:t>6/15/2026</a:t>
             </a:fld>
             <a:endParaRPr lang="en-US"/>
           </a:p>
@@ -2744,7 +2744,7 @@
           <a:p>
             <a:fld id="{5BCAD085-E8A6-8845-BD4E-CB4CCA059FC4}" type="datetimeFigureOut">
               <a:rPr lang="en-US" smtClean="0"/>
-              <a:t>6/10/2026</a:t>
+              <a:t>6/15/2026</a:t>
             </a:fld>
             <a:endParaRPr lang="en-US"/>
           </a:p>
@@ -3368,124 +3368,39 @@
           </a:bodyPr>
           <a:lstStyle/>
           <a:p>
-            <a:pPr algn="l"/>
-            <a:r>
-              <a:rPr sz="2300" b="0" i="0" dirty="0">
+            <a:r>
+              <a:rPr lang="it-IT" sz="2300" dirty="0">
                 <a:solidFill>
                   <a:srgbClr val="FFFFFF"/>
                 </a:solidFill>
                 <a:latin typeface="Aptos"/>
               </a:rPr>
-              <a:t>Dal graph JSON </a:t>
-            </a:r>
-            <a:r>
-              <a:rPr sz="2300" b="0" i="0" dirty="0" err="1">
+              <a:t>Dal </a:t>
+            </a:r>
+            <a:r>
+              <a:rPr lang="it-IT" sz="2300" dirty="0" err="1">
                 <a:solidFill>
                   <a:srgbClr val="FFFFFF"/>
                 </a:solidFill>
                 <a:latin typeface="Aptos"/>
               </a:rPr>
-              <a:t>prodotto</a:t>
-            </a:r>
-            <a:r>
-              <a:rPr sz="2300" b="0" i="0" dirty="0">
+              <a:t>graph</a:t>
+            </a:r>
+            <a:r>
+              <a:rPr lang="it-IT" sz="2300" dirty="0">
                 <a:solidFill>
                   <a:srgbClr val="FFFFFF"/>
                 </a:solidFill>
                 <a:latin typeface="Aptos"/>
               </a:rPr>
-              <a:t> </a:t>
-            </a:r>
-            <a:r>
-              <a:rPr sz="2300" b="0" i="0" dirty="0" err="1">
-                <a:solidFill>
-                  <a:srgbClr val="FFFFFF"/>
-                </a:solidFill>
-                <a:latin typeface="Aptos"/>
-              </a:rPr>
-              <a:t>dalla</a:t>
-            </a:r>
-            <a:r>
-              <a:rPr sz="2300" b="0" i="0" dirty="0">
-                <a:solidFill>
-                  <a:srgbClr val="FFFFFF"/>
-                </a:solidFill>
-                <a:latin typeface="Aptos"/>
-              </a:rPr>
-              <a:t> pipeline </a:t>
-            </a:r>
-            <a:r>
-              <a:rPr sz="2300" b="0" i="0" dirty="0" err="1">
-                <a:solidFill>
-                  <a:srgbClr val="FFFFFF"/>
-                </a:solidFill>
-                <a:latin typeface="Aptos"/>
-              </a:rPr>
-              <a:t>attuale</a:t>
-            </a:r>
-            <a:r>
-              <a:rPr sz="2300" b="0" i="0" dirty="0">
-                <a:solidFill>
-                  <a:srgbClr val="FFFFFF"/>
-                </a:solidFill>
-                <a:latin typeface="Aptos"/>
-              </a:rPr>
-              <a:t> a netlist SPICE, report </a:t>
-            </a:r>
-            <a:r>
-              <a:rPr sz="2300" b="0" i="0" dirty="0" err="1">
-                <a:solidFill>
-                  <a:srgbClr val="FFFFFF"/>
-                </a:solidFill>
-                <a:latin typeface="Aptos"/>
-              </a:rPr>
-              <a:t>elettrici</a:t>
-            </a:r>
-            <a:r>
-              <a:rPr sz="2300" b="0" i="0" dirty="0">
-                <a:solidFill>
-                  <a:srgbClr val="FFFFFF"/>
-                </a:solidFill>
-                <a:latin typeface="Aptos"/>
-              </a:rPr>
-              <a:t> e </a:t>
-            </a:r>
-            <a:r>
-              <a:rPr sz="2300" b="0" i="0" dirty="0" err="1">
-                <a:solidFill>
-                  <a:srgbClr val="FFFFFF"/>
-                </a:solidFill>
-                <a:latin typeface="Aptos"/>
-              </a:rPr>
-              <a:t>agente</a:t>
-            </a:r>
-            <a:r>
-              <a:rPr sz="2300" b="0" i="0" dirty="0">
-                <a:solidFill>
-                  <a:srgbClr val="FFFFFF"/>
-                </a:solidFill>
-                <a:latin typeface="Aptos"/>
-              </a:rPr>
-              <a:t> GPT </a:t>
-            </a:r>
-            <a:r>
-              <a:rPr sz="2300" b="0" i="0" dirty="0" err="1">
-                <a:solidFill>
-                  <a:srgbClr val="FFFFFF"/>
-                </a:solidFill>
-                <a:latin typeface="Aptos"/>
-              </a:rPr>
-              <a:t>diagnostico</a:t>
-            </a:r>
-            <a:r>
-              <a:rPr sz="2300" b="0" i="0" dirty="0">
-                <a:solidFill>
-                  <a:srgbClr val="FFFFFF"/>
-                </a:solidFill>
-                <a:latin typeface="Aptos"/>
-              </a:rPr>
-              <a:t>.</a:t>
-            </a:r>
+              <a:t> JSON prodotto dalla pipeline attuale alla simulazione SPICE e al contesto diagnostico per un agente AI.</a:t>
+            </a:r>
+            <a:endParaRPr sz="2300" b="0" i="0" dirty="0">
+              <a:solidFill>
+                <a:srgbClr val="FFFFFF"/>
+              </a:solidFill>
+              <a:latin typeface="Aptos"/>
+            </a:endParaRPr>
           </a:p>
         </p:txBody>
       </p:sp>
@@ -3640,13 +3555,31 @@
           <a:p>
             <a:pPr algn="ctr"/>
             <a:r>
-              <a:rPr sz="1100" b="1" i="0" dirty="0" err="1">
+              <a:rPr lang="it-IT" sz="1100" b="1" i="0" dirty="0" err="1">
                 <a:solidFill>
                   <a:srgbClr val="FFFFFF"/>
                 </a:solidFill>
                 <a:latin typeface="Aptos"/>
               </a:rPr>
-              <a:t>values.yaml</a:t>
+              <a:t>Node</a:t>
+            </a:r>
+            <a:r>
+              <a:rPr lang="it-IT" sz="1100" b="1" i="0" dirty="0">
+                <a:solidFill>
+                  <a:srgbClr val="FFFFFF"/>
+                </a:solidFill>
+                <a:latin typeface="Aptos"/>
+              </a:rPr>
+              <a:t> </a:t>
+            </a:r>
+            <a:r>
+              <a:rPr lang="it-IT" sz="1100" b="1" i="0" dirty="0" err="1">
+                <a:solidFill>
+                  <a:srgbClr val="FFFFFF"/>
+                </a:solidFill>
+                <a:latin typeface="Aptos"/>
+              </a:rPr>
+              <a:t>map</a:t>
             </a:r>
             <a:endParaRPr sz="1100" b="1" i="0" dirty="0">
               <a:solidFill>
@@ -3727,13 +3660,31 @@
           <a:p>
             <a:pPr algn="ctr"/>
             <a:r>
-              <a:rPr sz="1100" b="1" i="0" dirty="0" err="1">
+              <a:rPr lang="it-IT" sz="1100" b="1" i="0" dirty="0" err="1">
                 <a:solidFill>
                   <a:srgbClr val="FFFFFF"/>
                 </a:solidFill>
                 <a:latin typeface="Aptos"/>
               </a:rPr>
-              <a:t>ngspice</a:t>
+              <a:t>Values</a:t>
+            </a:r>
+            <a:r>
+              <a:rPr lang="it-IT" sz="1100" b="1" dirty="0" err="1">
+                <a:solidFill>
+                  <a:srgbClr val="FFFFFF"/>
+                </a:solidFill>
+                <a:latin typeface="Aptos"/>
+              </a:rPr>
+              <a:t>.</a:t>
+            </a:r>
+            <a:r>
+              <a:rPr lang="it-IT" sz="1100" b="1" i="0" dirty="0" err="1">
+                <a:solidFill>
+                  <a:srgbClr val="FFFFFF"/>
+                </a:solidFill>
+                <a:latin typeface="Aptos"/>
+              </a:rPr>
+              <a:t>yaml</a:t>
             </a:r>
             <a:endParaRPr sz="1100" b="1" i="0" dirty="0">
               <a:solidFill>
@@ -3814,14 +3765,20 @@
           <a:p>
             <a:pPr algn="ctr"/>
             <a:r>
-              <a:rPr sz="1100" b="1" i="0" dirty="0">
+              <a:rPr lang="it-IT" sz="1100" b="1" i="0" dirty="0">
                 <a:solidFill>
                   <a:srgbClr val="FFFFFF"/>
                 </a:solidFill>
                 <a:latin typeface="Aptos"/>
               </a:rPr>
-              <a:t>device profiles</a:t>
-            </a:r>
+              <a:t>Component rules</a:t>
+            </a:r>
+            <a:endParaRPr sz="1100" b="1" i="0" dirty="0">
+              <a:solidFill>
+                <a:srgbClr val="FFFFFF"/>
+              </a:solidFill>
+              <a:latin typeface="Aptos"/>
+            </a:endParaRPr>
           </a:p>
         </p:txBody>
       </p:sp>
@@ -3895,14 +3852,20 @@
           <a:p>
             <a:pPr algn="ctr"/>
             <a:r>
-              <a:rPr sz="1100" b="1" i="0" dirty="0">
+              <a:rPr lang="it-IT" sz="1100" b="1" i="0" dirty="0" err="1">
                 <a:solidFill>
                   <a:srgbClr val="FFFFFF"/>
                 </a:solidFill>
                 <a:latin typeface="Aptos"/>
               </a:rPr>
-              <a:t>report</a:t>
-            </a:r>
+              <a:t>ngspice</a:t>
+            </a:r>
+            <a:endParaRPr sz="1100" b="1" i="0" dirty="0">
+              <a:solidFill>
+                <a:srgbClr val="FFFFFF"/>
+              </a:solidFill>
+              <a:latin typeface="Aptos"/>
+            </a:endParaRPr>
           </a:p>
         </p:txBody>
       </p:sp>
@@ -3976,14 +3939,20 @@
           <a:p>
             <a:pPr algn="ctr"/>
             <a:r>
-              <a:rPr sz="1100" b="1" i="0" dirty="0">
+              <a:rPr lang="it-IT" sz="1100" b="1" i="0" dirty="0">
                 <a:solidFill>
                   <a:srgbClr val="FFFFFF"/>
                 </a:solidFill>
                 <a:latin typeface="Aptos"/>
               </a:rPr>
-              <a:t>GPT agent</a:t>
-            </a:r>
+              <a:t>AI Agent</a:t>
+            </a:r>
+            <a:endParaRPr sz="1100" b="1" i="0" dirty="0">
+              <a:solidFill>
+                <a:srgbClr val="FFFFFF"/>
+              </a:solidFill>
+              <a:latin typeface="Aptos"/>
+            </a:endParaRPr>
           </a:p>
         </p:txBody>
       </p:sp>
@@ -4588,23 +4557,20 @@
           <a:p>
             <a:pPr algn="l"/>
             <a:r>
-              <a:rPr sz="1500" b="1" i="0" dirty="0" err="1">
+              <a:rPr lang="it-IT" sz="1500" b="1" i="0" dirty="0">
                 <a:solidFill>
                   <a:srgbClr val="0B1F33"/>
                 </a:solidFill>
                 <a:latin typeface="Aptos"/>
               </a:rPr>
-              <a:t>Costruttore</a:t>
-            </a:r>
-            <a:r>
-              <a:rPr sz="1500" b="1" i="0" dirty="0">
-                <a:solidFill>
-                  <a:srgbClr val="0B1F33"/>
-                </a:solidFill>
-                <a:latin typeface="Aptos"/>
-              </a:rPr>
-              <a:t> nodi</a:t>
-            </a:r>
+              <a:t>Ricostruzione nodi</a:t>
+            </a:r>
+            <a:endParaRPr sz="1500" b="1" i="0" dirty="0">
+              <a:solidFill>
+                <a:srgbClr val="0B1F33"/>
+              </a:solidFill>
+              <a:latin typeface="Aptos"/>
+            </a:endParaRPr>
           </a:p>
         </p:txBody>
       </p:sp>
@@ -4794,14 +4760,20 @@
           <a:p>
             <a:pPr algn="l"/>
             <a:r>
-              <a:rPr sz="1500" b="1" i="0" dirty="0">
+              <a:rPr lang="it-IT" sz="1500" b="1" i="0" dirty="0">
                 <a:solidFill>
                   <a:srgbClr val="0B1F33"/>
                 </a:solidFill>
                 <a:latin typeface="Aptos"/>
               </a:rPr>
-              <a:t>Binder YAML</a:t>
-            </a:r>
+              <a:t>Binding valori</a:t>
+            </a:r>
+            <a:endParaRPr sz="1500" b="1" i="0" dirty="0">
+              <a:solidFill>
+                <a:srgbClr val="0B1F33"/>
+              </a:solidFill>
+              <a:latin typeface="Aptos"/>
+            </a:endParaRPr>
           </a:p>
         </p:txBody>
       </p:sp>
@@ -4976,7 +4948,7 @@
         <p:spPr>
           <a:xfrm>
             <a:off x="9957816" y="1435608"/>
-            <a:ext cx="1645920" cy="249299"/>
+            <a:ext cx="1746504" cy="249299"/>
           </a:xfrm>
           <a:prstGeom prst="rect">
             <a:avLst/>
@@ -4991,23 +4963,20 @@
           <a:p>
             <a:pPr algn="l"/>
             <a:r>
-              <a:rPr sz="1500" b="1" i="0" dirty="0" err="1">
+              <a:rPr lang="it-IT" sz="1500" b="1" i="0" dirty="0">
                 <a:solidFill>
                   <a:srgbClr val="0B1F33"/>
                 </a:solidFill>
                 <a:latin typeface="Aptos"/>
               </a:rPr>
-              <a:t>Generatore</a:t>
-            </a:r>
-            <a:r>
-              <a:rPr sz="1500" b="1" i="0" dirty="0">
-                <a:solidFill>
-                  <a:srgbClr val="0B1F33"/>
-                </a:solidFill>
-                <a:latin typeface="Aptos"/>
-              </a:rPr>
-              <a:t> netlist</a:t>
-            </a:r>
+              <a:t>Regole componenti</a:t>
+            </a:r>
+            <a:endParaRPr sz="1500" b="1" i="0" dirty="0">
+              <a:solidFill>
+                <a:srgbClr val="0B1F33"/>
+              </a:solidFill>
+              <a:latin typeface="Aptos"/>
+            </a:endParaRPr>
           </a:p>
         </p:txBody>
       </p:sp>
@@ -5019,7 +4988,7 @@
         </p:nvSpPr>
         <p:spPr>
           <a:xfrm>
-            <a:off x="548640" y="3383280"/>
+            <a:off x="548640" y="3115318"/>
             <a:ext cx="2560320" cy="1417320"/>
           </a:xfrm>
           <a:prstGeom prst="roundRect">
@@ -5065,7 +5034,7 @@
         </p:nvSpPr>
         <p:spPr>
           <a:xfrm>
-            <a:off x="685800" y="3547872"/>
+            <a:off x="685800" y="3279910"/>
             <a:ext cx="411480" cy="411480"/>
           </a:xfrm>
           <a:prstGeom prst="ellipse">
@@ -5111,7 +5080,7 @@
         </p:nvSpPr>
         <p:spPr>
           <a:xfrm>
-            <a:off x="685800" y="3639312"/>
+            <a:off x="685800" y="3371350"/>
             <a:ext cx="411480" cy="184666"/>
           </a:xfrm>
           <a:prstGeom prst="rect">
@@ -5146,8 +5115,8 @@
         </p:nvSpPr>
         <p:spPr>
           <a:xfrm>
-            <a:off x="1234440" y="3584448"/>
-            <a:ext cx="1645920" cy="249299"/>
+            <a:off x="1234440" y="3316486"/>
+            <a:ext cx="1645920" cy="480131"/>
           </a:xfrm>
           <a:prstGeom prst="rect">
             <a:avLst/>
@@ -5162,23 +5131,29 @@
           <a:p>
             <a:pPr algn="l"/>
             <a:r>
-              <a:rPr sz="1500" b="1" i="0" dirty="0" err="1">
+              <a:rPr lang="it-IT" sz="1500" b="1" i="0" dirty="0">
                 <a:solidFill>
                   <a:srgbClr val="0B1F33"/>
                 </a:solidFill>
                 <a:latin typeface="Aptos"/>
               </a:rPr>
-              <a:t>Esecutore</a:t>
-            </a:r>
-            <a:r>
-              <a:rPr sz="1500" b="1" i="0" dirty="0">
+              <a:t>Generazione </a:t>
+            </a:r>
+            <a:r>
+              <a:rPr lang="it-IT" sz="1500" b="1" i="0" dirty="0" err="1">
                 <a:solidFill>
                   <a:srgbClr val="0B1F33"/>
                 </a:solidFill>
                 <a:latin typeface="Aptos"/>
               </a:rPr>
-              <a:t> SPICE</a:t>
-            </a:r>
+              <a:t>netlist</a:t>
+            </a:r>
+            <a:endParaRPr sz="1500" b="1" i="0" dirty="0">
+              <a:solidFill>
+                <a:srgbClr val="0B1F33"/>
+              </a:solidFill>
+              <a:latin typeface="Aptos"/>
+            </a:endParaRPr>
           </a:p>
         </p:txBody>
       </p:sp>
@@ -5190,7 +5165,7 @@
         </p:nvCxnSpPr>
         <p:spPr>
           <a:xfrm>
-            <a:off x="3108960" y="4096512"/>
+            <a:off x="3108960" y="3828550"/>
             <a:ext cx="292608" cy="0"/>
           </a:xfrm>
           <a:prstGeom prst="line">
@@ -5225,7 +5200,7 @@
         </p:nvSpPr>
         <p:spPr>
           <a:xfrm>
-            <a:off x="3456432" y="3383280"/>
+            <a:off x="3456432" y="3115318"/>
             <a:ext cx="2560320" cy="1417320"/>
           </a:xfrm>
           <a:prstGeom prst="roundRect">
@@ -5271,7 +5246,7 @@
         </p:nvSpPr>
         <p:spPr>
           <a:xfrm>
-            <a:off x="3593592" y="3547872"/>
+            <a:off x="3593592" y="3279910"/>
             <a:ext cx="411480" cy="411480"/>
           </a:xfrm>
           <a:prstGeom prst="ellipse">
@@ -5317,7 +5292,7 @@
         </p:nvSpPr>
         <p:spPr>
           <a:xfrm>
-            <a:off x="3593592" y="3639312"/>
+            <a:off x="3593592" y="3371350"/>
             <a:ext cx="411480" cy="184666"/>
           </a:xfrm>
           <a:prstGeom prst="rect">
@@ -5352,7 +5327,7 @@
         </p:nvSpPr>
         <p:spPr>
           <a:xfrm>
-            <a:off x="4142232" y="3584448"/>
+            <a:off x="4142232" y="3316486"/>
             <a:ext cx="1645920" cy="249299"/>
           </a:xfrm>
           <a:prstGeom prst="rect">
@@ -5368,22 +5343,13 @@
           <a:p>
             <a:pPr algn="l"/>
             <a:r>
-              <a:rPr sz="1500" b="1" i="0" dirty="0">
+              <a:rPr lang="it-IT" sz="1500" b="1" i="0" dirty="0">
                 <a:solidFill>
                   <a:srgbClr val="0B1F33"/>
                 </a:solidFill>
                 <a:latin typeface="Aptos"/>
               </a:rPr>
-              <a:t>Report </a:t>
-            </a:r>
-            <a:r>
-              <a:rPr sz="1500" b="1" i="0" dirty="0" err="1">
-                <a:solidFill>
-                  <a:srgbClr val="0B1F33"/>
-                </a:solidFill>
-                <a:latin typeface="Aptos"/>
-              </a:rPr>
-              <a:t>elettrico</a:t>
+              <a:t>Esecuzione SPICE</a:t>
             </a:r>
             <a:endParaRPr sz="1500" b="1" i="0" dirty="0">
               <a:solidFill>
@@ -5402,7 +5368,7 @@
         </p:nvCxnSpPr>
         <p:spPr>
           <a:xfrm>
-            <a:off x="6016752" y="4096512"/>
+            <a:off x="6016752" y="3828550"/>
             <a:ext cx="292608" cy="0"/>
           </a:xfrm>
           <a:prstGeom prst="line">
@@ -5437,7 +5403,7 @@
         </p:nvSpPr>
         <p:spPr>
           <a:xfrm>
-            <a:off x="6364224" y="3383280"/>
+            <a:off x="6364224" y="3115318"/>
             <a:ext cx="2560320" cy="1417320"/>
           </a:xfrm>
           <a:prstGeom prst="roundRect">
@@ -5483,7 +5449,7 @@
         </p:nvSpPr>
         <p:spPr>
           <a:xfrm>
-            <a:off x="6501384" y="3547872"/>
+            <a:off x="6501384" y="3279910"/>
             <a:ext cx="411480" cy="411480"/>
           </a:xfrm>
           <a:prstGeom prst="ellipse">
@@ -5529,7 +5495,7 @@
         </p:nvSpPr>
         <p:spPr>
           <a:xfrm>
-            <a:off x="6501384" y="3639312"/>
+            <a:off x="6501384" y="3371350"/>
             <a:ext cx="411480" cy="184666"/>
           </a:xfrm>
           <a:prstGeom prst="rect">
@@ -5564,8 +5530,8 @@
         </p:nvSpPr>
         <p:spPr>
           <a:xfrm>
-            <a:off x="7050024" y="3584448"/>
-            <a:ext cx="1645920" cy="480131"/>
+            <a:off x="7050024" y="3316486"/>
+            <a:ext cx="1645920" cy="249299"/>
           </a:xfrm>
           <a:prstGeom prst="rect">
             <a:avLst/>
@@ -5580,31 +5546,13 @@
           <a:p>
             <a:pPr algn="l"/>
             <a:r>
-              <a:rPr sz="1500" b="1" i="0" dirty="0" err="1">
+              <a:rPr lang="it-IT" sz="1500" b="1" i="0" dirty="0">
                 <a:solidFill>
                   <a:srgbClr val="0B1F33"/>
                 </a:solidFill>
                 <a:latin typeface="Aptos"/>
               </a:rPr>
-              <a:t>Contesto</a:t>
-            </a:r>
-            <a:r>
-              <a:rPr sz="1500" b="1" i="0" dirty="0">
-                <a:solidFill>
-                  <a:srgbClr val="0B1F33"/>
-                </a:solidFill>
-                <a:latin typeface="Aptos"/>
-              </a:rPr>
-              <a:t> </a:t>
-            </a:r>
-            <a:r>
-              <a:rPr sz="1500" b="1" i="0" dirty="0" err="1">
-                <a:solidFill>
-                  <a:srgbClr val="0B1F33"/>
-                </a:solidFill>
-                <a:latin typeface="Aptos"/>
-              </a:rPr>
-              <a:t>diagnostico</a:t>
+              <a:t>Report elettrico</a:t>
             </a:r>
             <a:endParaRPr sz="1500" b="1" i="0" dirty="0">
               <a:solidFill>
@@ -5623,7 +5571,7 @@
         </p:nvCxnSpPr>
         <p:spPr>
           <a:xfrm>
-            <a:off x="8924544" y="4096512"/>
+            <a:off x="8924544" y="3828550"/>
             <a:ext cx="292608" cy="0"/>
           </a:xfrm>
           <a:prstGeom prst="line">
@@ -5658,7 +5606,7 @@
         </p:nvSpPr>
         <p:spPr>
           <a:xfrm>
-            <a:off x="9272016" y="3383280"/>
+            <a:off x="9272016" y="3115318"/>
             <a:ext cx="2560320" cy="1417320"/>
           </a:xfrm>
           <a:prstGeom prst="roundRect">
@@ -5704,7 +5652,7 @@
         </p:nvSpPr>
         <p:spPr>
           <a:xfrm>
-            <a:off x="9409176" y="3547872"/>
+            <a:off x="9409176" y="3279910"/>
             <a:ext cx="411480" cy="411480"/>
           </a:xfrm>
           <a:prstGeom prst="ellipse">
@@ -5750,7 +5698,7 @@
         </p:nvSpPr>
         <p:spPr>
           <a:xfrm>
-            <a:off x="9409176" y="3639312"/>
+            <a:off x="9409176" y="3371350"/>
             <a:ext cx="411480" cy="184666"/>
           </a:xfrm>
           <a:prstGeom prst="rect">
@@ -5785,8 +5733,8 @@
         </p:nvSpPr>
         <p:spPr>
           <a:xfrm>
-            <a:off x="9957816" y="3584448"/>
-            <a:ext cx="1645920" cy="249299"/>
+            <a:off x="9957816" y="3316486"/>
+            <a:ext cx="1645920" cy="480131"/>
           </a:xfrm>
           <a:prstGeom prst="rect">
             <a:avLst/>
@@ -5801,23 +5749,20 @@
           <a:p>
             <a:pPr algn="l"/>
             <a:r>
-              <a:rPr sz="1500" b="1" i="0" dirty="0" err="1">
+              <a:rPr lang="it-IT" sz="1500" b="1" i="0" dirty="0">
                 <a:solidFill>
                   <a:srgbClr val="0B1F33"/>
                 </a:solidFill>
                 <a:latin typeface="Aptos"/>
               </a:rPr>
-              <a:t>Agente</a:t>
-            </a:r>
-            <a:r>
-              <a:rPr sz="1500" b="1" i="0" dirty="0">
-                <a:solidFill>
-                  <a:srgbClr val="0B1F33"/>
-                </a:solidFill>
-                <a:latin typeface="Aptos"/>
-              </a:rPr>
-              <a:t> AI</a:t>
-            </a:r>
+              <a:t>Contesto Diagnostico</a:t>
+            </a:r>
+            <a:endParaRPr sz="1500" b="1" i="0" dirty="0">
+              <a:solidFill>
+                <a:srgbClr val="0B1F33"/>
+              </a:solidFill>
+              <a:latin typeface="Aptos"/>
+            </a:endParaRPr>
           </a:p>
         </p:txBody>
       </p:sp>
@@ -5929,6 +5874,161 @@
               </a:rPr>
               <a:t>10</a:t>
             </a:r>
+          </a:p>
+        </p:txBody>
+      </p:sp>
+      <p:sp>
+        <p:nvSpPr>
+          <p:cNvPr id="47" name="Rounded Rectangle 39">
+            <a:extLst>
+              <a:ext uri="{FF2B5EF4-FFF2-40B4-BE49-F238E27FC236}">
+                <a16:creationId xmlns:a16="http://schemas.microsoft.com/office/drawing/2014/main" id="{A800B406-EDEF-0680-86D6-06F31B7C79E9}"/>
+              </a:ext>
+            </a:extLst>
+          </p:cNvPr>
+          <p:cNvSpPr/>
+          <p:nvPr/>
+        </p:nvSpPr>
+        <p:spPr>
+          <a:xfrm>
+            <a:off x="548640" y="4914901"/>
+            <a:ext cx="2560320" cy="1417320"/>
+          </a:xfrm>
+          <a:prstGeom prst="roundRect">
+            <a:avLst/>
+          </a:prstGeom>
+          <a:solidFill>
+            <a:srgbClr val="FFFFFF"/>
+          </a:solidFill>
+          <a:ln w="12700">
+            <a:solidFill>
+              <a:srgbClr val="CBD5E1"/>
+            </a:solidFill>
+          </a:ln>
+        </p:spPr>
+        <p:style>
+          <a:lnRef idx="1">
+            <a:schemeClr val="accent1"/>
+          </a:lnRef>
+          <a:fillRef idx="3">
+            <a:schemeClr val="accent1"/>
+          </a:fillRef>
+          <a:effectRef idx="2">
+            <a:schemeClr val="accent1"/>
+          </a:effectRef>
+          <a:fontRef idx="minor">
+            <a:schemeClr val="lt1"/>
+          </a:fontRef>
+        </p:style>
+        <p:txBody>
+          <a:bodyPr rtlCol="0" anchor="ctr"/>
+          <a:lstStyle/>
+          <a:p>
+            <a:pPr algn="ctr"/>
+            <a:endParaRPr/>
+          </a:p>
+        </p:txBody>
+      </p:sp>
+      <p:sp>
+        <p:nvSpPr>
+          <p:cNvPr id="48" name="Oval 40">
+            <a:extLst>
+              <a:ext uri="{FF2B5EF4-FFF2-40B4-BE49-F238E27FC236}">
+                <a16:creationId xmlns:a16="http://schemas.microsoft.com/office/drawing/2014/main" id="{F8275E6E-56E2-1C26-0BBD-1B093E400051}"/>
+              </a:ext>
+            </a:extLst>
+          </p:cNvPr>
+          <p:cNvSpPr/>
+          <p:nvPr/>
+        </p:nvSpPr>
+        <p:spPr>
+          <a:xfrm>
+            <a:off x="771537" y="5090886"/>
+            <a:ext cx="411480" cy="411480"/>
+          </a:xfrm>
+          <a:prstGeom prst="ellipse">
+            <a:avLst/>
+          </a:prstGeom>
+          <a:solidFill>
+            <a:srgbClr val="0B1F33"/>
+          </a:solidFill>
+          <a:ln>
+            <a:solidFill>
+              <a:srgbClr val="0B1F33"/>
+            </a:solidFill>
+          </a:ln>
+        </p:spPr>
+        <p:style>
+          <a:lnRef idx="1">
+            <a:schemeClr val="accent1"/>
+          </a:lnRef>
+          <a:fillRef idx="3">
+            <a:schemeClr val="accent1"/>
+          </a:fillRef>
+          <a:effectRef idx="2">
+            <a:schemeClr val="accent1"/>
+          </a:effectRef>
+          <a:fontRef idx="minor">
+            <a:schemeClr val="lt1"/>
+          </a:fontRef>
+        </p:style>
+        <p:txBody>
+          <a:bodyPr rtlCol="0" anchor="ctr"/>
+          <a:lstStyle/>
+          <a:p>
+            <a:pPr algn="ctr"/>
+            <a:r>
+              <a:rPr lang="it-IT" dirty="0"/>
+              <a:t>9</a:t>
+            </a:r>
+            <a:endParaRPr dirty="0"/>
+          </a:p>
+        </p:txBody>
+      </p:sp>
+      <p:sp>
+        <p:nvSpPr>
+          <p:cNvPr id="50" name="TextBox 42">
+            <a:extLst>
+              <a:ext uri="{FF2B5EF4-FFF2-40B4-BE49-F238E27FC236}">
+                <a16:creationId xmlns:a16="http://schemas.microsoft.com/office/drawing/2014/main" id="{AD9EE650-A676-0AA4-2CE9-AE25E20C3191}"/>
+              </a:ext>
+            </a:extLst>
+          </p:cNvPr>
+          <p:cNvSpPr txBox="1"/>
+          <p:nvPr/>
+        </p:nvSpPr>
+        <p:spPr>
+          <a:xfrm>
+            <a:off x="1320177" y="5127462"/>
+            <a:ext cx="1645920" cy="249299"/>
+          </a:xfrm>
+          <a:prstGeom prst="rect">
+            <a:avLst/>
+          </a:prstGeom>
+          <a:noFill/>
+        </p:spPr>
+        <p:txBody>
+          <a:bodyPr wrap="square" lIns="9144" tIns="9144" rIns="9144" bIns="9144" anchor="t">
+            <a:spAutoFit/>
+          </a:bodyPr>
+          <a:lstStyle/>
+          <a:p>
+            <a:pPr algn="l"/>
+            <a:r>
+              <a:rPr lang="it-IT" sz="1500" b="1" i="0" dirty="0">
+                <a:solidFill>
+                  <a:srgbClr val="0B1F33"/>
+                </a:solidFill>
+                <a:latin typeface="Aptos"/>
+              </a:rPr>
+              <a:t>Agente AI</a:t>
+            </a:r>
+            <a:endParaRPr sz="1500" b="1" i="0" dirty="0">
+              <a:solidFill>
+                <a:srgbClr val="0B1F33"/>
+              </a:solidFill>
+              <a:latin typeface="Aptos"/>
+            </a:endParaRPr>
           </a:p>
         </p:txBody>
       </p:sp>
@@ -7188,7 +7288,25 @@
                 </a:solidFill>
                 <a:latin typeface="Aptos Display"/>
               </a:rPr>
-              <a:t>4: dal YAML alla netlist SPICE</a:t>
+              <a:t>4</a:t>
+            </a:r>
+            <a:r>
+              <a:rPr lang="it-IT" sz="2800" b="1" i="0" dirty="0">
+                <a:solidFill>
+                  <a:srgbClr val="0B1F33"/>
+                </a:solidFill>
+                <a:latin typeface="Aptos Display"/>
+              </a:rPr>
+              <a:t> - 5</a:t>
+            </a:r>
+            <a:r>
+              <a:rPr sz="2800" b="1" i="0" dirty="0">
+                <a:solidFill>
+                  <a:srgbClr val="0B1F33"/>
+                </a:solidFill>
+                <a:latin typeface="Aptos Display"/>
+              </a:rPr>
+              <a:t>: dal YAML alla netlist SPICE</a:t>
             </a:r>
           </a:p>
         </p:txBody>
@@ -8257,7 +8375,7 @@
         <p:spPr>
           <a:xfrm>
             <a:off x="457200" y="256032"/>
-            <a:ext cx="9692640" cy="411480"/>
+            <a:ext cx="9692640" cy="523220"/>
           </a:xfrm>
           <a:prstGeom prst="rect">
             <a:avLst/>
@@ -8272,13 +8390,49 @@
           <a:p>
             <a:pPr algn="l"/>
             <a:r>
-              <a:rPr sz="2800" b="1" i="0">
+              <a:rPr sz="2800" b="1" i="0" dirty="0">
                 <a:solidFill>
                   <a:srgbClr val="0B1F33"/>
                 </a:solidFill>
                 <a:latin typeface="Aptos Display"/>
               </a:rPr>
-              <a:t>Modulo 5: esecuzione SPICE</a:t>
+              <a:t>Modulo </a:t>
+            </a:r>
+            <a:r>
+              <a:rPr lang="it-IT" sz="2800" b="1" i="0" dirty="0">
+                <a:solidFill>
+                  <a:srgbClr val="0B1F33"/>
+                </a:solidFill>
+                <a:latin typeface="Aptos Display"/>
+              </a:rPr>
+              <a:t>6</a:t>
+            </a:r>
+            <a:r>
+              <a:rPr sz="2800" b="1" i="0" dirty="0">
+                <a:solidFill>
+                  <a:srgbClr val="0B1F33"/>
+                </a:solidFill>
+                <a:latin typeface="Aptos Display"/>
+              </a:rPr>
+              <a:t>: </a:t>
+            </a:r>
+            <a:r>
+              <a:rPr sz="2800" b="1" i="0" dirty="0" err="1">
+                <a:solidFill>
+                  <a:srgbClr val="0B1F33"/>
+                </a:solidFill>
+                <a:latin typeface="Aptos Display"/>
+              </a:rPr>
+              <a:t>esecuzione</a:t>
+            </a:r>
+            <a:r>
+              <a:rPr sz="2800" b="1" i="0" dirty="0">
+                <a:solidFill>
+                  <a:srgbClr val="0B1F33"/>
+                </a:solidFill>
+                <a:latin typeface="Aptos Display"/>
+              </a:rPr>
+              <a:t> SPICE</a:t>
             </a:r>
           </a:p>
         </p:txBody>
@@ -14609,7 +14763,25 @@
                 </a:solidFill>
                 <a:latin typeface="Aptos Display"/>
               </a:rPr>
-              <a:t>8: </a:t>
+              <a:t>8</a:t>
+            </a:r>
+            <a:r>
+              <a:rPr lang="it-IT" sz="2800" b="1" i="0" dirty="0">
+                <a:solidFill>
+                  <a:srgbClr val="0B1F33"/>
+                </a:solidFill>
+                <a:latin typeface="Aptos Display"/>
+              </a:rPr>
+              <a:t> - 9</a:t>
+            </a:r>
+            <a:r>
+              <a:rPr sz="2800" b="1" i="0" dirty="0">
+                <a:solidFill>
+                  <a:srgbClr val="0B1F33"/>
+                </a:solidFill>
+                <a:latin typeface="Aptos Display"/>
+              </a:rPr>
+              <a:t>: </a:t>
             </a:r>
             <a:r>
               <a:rPr sz="2800" b="1" i="0" dirty="0" err="1">
@@ -15572,7 +15744,7 @@
         <p:spPr>
           <a:xfrm>
             <a:off x="5879592" y="1691640"/>
-            <a:ext cx="5148072" cy="2811026"/>
+            <a:ext cx="5148072" cy="3375283"/>
           </a:xfrm>
           <a:prstGeom prst="rect">
             <a:avLst/>
@@ -15967,6 +16139,45 @@
                 <a:latin typeface="Aptos"/>
               </a:rPr>
               <a:t>ipotesi</a:t>
+            </a:r>
+            <a:endParaRPr lang="it-IT" sz="1500" b="0" dirty="0">
+              <a:solidFill>
+                <a:srgbClr val="0F172A"/>
+              </a:solidFill>
+              <a:latin typeface="Aptos"/>
+            </a:endParaRPr>
+          </a:p>
+          <a:p>
+            <a:pPr marL="285750" indent="-285750">
+              <a:spcAft>
+                <a:spcPts val="400"/>
+              </a:spcAft>
+              <a:buFont typeface="Arial" panose="020B0604020202020204" pitchFamily="34" charset="0"/>
+              <a:buChar char="•"/>
+            </a:pPr>
+            <a:endParaRPr lang="it-IT" sz="1500" b="0" dirty="0">
+              <a:solidFill>
+                <a:srgbClr val="0F172A"/>
+              </a:solidFill>
+              <a:latin typeface="Aptos"/>
+            </a:endParaRPr>
+          </a:p>
+          <a:p>
+            <a:pPr marL="285750" indent="-285750">
+              <a:spcAft>
+                <a:spcPts val="400"/>
+              </a:spcAft>
+              <a:buFont typeface="Arial" panose="020B0604020202020204" pitchFamily="34" charset="0"/>
+              <a:buChar char="•"/>
+            </a:pPr>
+            <a:r>
+              <a:rPr lang="it-IT" sz="1500" dirty="0">
+                <a:solidFill>
+                  <a:srgbClr val="0F172A"/>
+                </a:solidFill>
+                <a:latin typeface="Aptos"/>
+              </a:rPr>
+              <a:t>propone scenari risolutivi</a:t>
             </a:r>
             <a:endParaRPr sz="1500" b="0" dirty="0">
               <a:solidFill>
@@ -18565,7 +18776,7 @@
         <p:spPr>
           <a:xfrm>
             <a:off x="8302752" y="1691640"/>
-            <a:ext cx="3227832" cy="2195473"/>
+            <a:ext cx="3227832" cy="2426305"/>
           </a:xfrm>
           <a:prstGeom prst="rect">
             <a:avLst/>
@@ -18597,49 +18808,10 @@
               </a:spcAft>
             </a:pPr>
             <a:r>
-              <a:rPr sz="1500" b="0" dirty="0">
-                <a:solidFill>
-                  <a:srgbClr val="0F172A"/>
-                </a:solidFill>
-                <a:latin typeface="Aptos"/>
-              </a:rPr>
-              <a:t>Report </a:t>
-            </a:r>
-            <a:r>
-              <a:rPr sz="1500" b="0" dirty="0" err="1">
-                <a:solidFill>
-                  <a:srgbClr val="0F172A"/>
-                </a:solidFill>
-                <a:latin typeface="Aptos"/>
-              </a:rPr>
-              <a:t>elettrico</a:t>
-            </a:r>
-            <a:r>
-              <a:rPr sz="1500" b="0" dirty="0">
-                <a:solidFill>
-                  <a:srgbClr val="0F172A"/>
-                </a:solidFill>
-                <a:latin typeface="Aptos"/>
-              </a:rPr>
-              <a:t> e </a:t>
-            </a:r>
-            <a:r>
-              <a:rPr sz="1500" b="0" dirty="0" err="1">
-                <a:solidFill>
-                  <a:srgbClr val="0F172A"/>
-                </a:solidFill>
-                <a:latin typeface="Aptos"/>
-              </a:rPr>
-              <a:t>visualizzazioni</a:t>
-            </a:r>
-            <a:r>
-              <a:rPr sz="1500" b="0" dirty="0">
-                <a:solidFill>
-                  <a:srgbClr val="0F172A"/>
-                </a:solidFill>
-                <a:latin typeface="Aptos"/>
-              </a:rPr>
-              <a:t>.</a:t>
+              <a:rPr lang="it-IT" sz="1500" dirty="0">
+                <a:latin typeface="Aptos" panose="020B0004020202020204" pitchFamily="34" charset="0"/>
+              </a:rPr>
+              <a:t>Risultati SPICE e file intermedi strutturati.</a:t>
             </a:r>
           </a:p>
           <a:p>
@@ -18698,13 +18870,13 @@
               <a:t> </a:t>
             </a:r>
             <a:r>
-              <a:rPr sz="1500" b="0" dirty="0" err="1">
-                <a:solidFill>
-                  <a:srgbClr val="0F172A"/>
-                </a:solidFill>
-                <a:latin typeface="Aptos"/>
-              </a:rPr>
-              <a:t>strutturato</a:t>
+              <a:rPr lang="it-IT" sz="1500" b="0" dirty="0">
+                <a:solidFill>
+                  <a:srgbClr val="0F172A"/>
+                </a:solidFill>
+                <a:latin typeface="Aptos"/>
+              </a:rPr>
+              <a:t>per un agente AI</a:t>
             </a:r>
             <a:r>
               <a:rPr sz="1500" b="0" dirty="0">
@@ -18713,7 +18885,7 @@
                 </a:solidFill>
                 <a:latin typeface="Aptos"/>
               </a:rPr>
-              <a:t> per GPT.</a:t>
+              <a:t>.</a:t>
             </a:r>
           </a:p>
           <a:p>
@@ -18736,77 +18908,20 @@
               </a:spcAft>
             </a:pPr>
             <a:r>
-              <a:rPr sz="1500" b="0" dirty="0" err="1">
-                <a:solidFill>
-                  <a:srgbClr val="0F172A"/>
-                </a:solidFill>
-                <a:latin typeface="Aptos"/>
-              </a:rPr>
-              <a:t>Risposte</a:t>
-            </a:r>
-            <a:r>
-              <a:rPr sz="1500" b="0" dirty="0">
-                <a:solidFill>
-                  <a:srgbClr val="0F172A"/>
-                </a:solidFill>
-                <a:latin typeface="Aptos"/>
-              </a:rPr>
-              <a:t> </a:t>
-            </a:r>
-            <a:r>
-              <a:rPr sz="1500" b="0" dirty="0" err="1">
-                <a:solidFill>
-                  <a:srgbClr val="0F172A"/>
-                </a:solidFill>
-                <a:latin typeface="Aptos"/>
-              </a:rPr>
-              <a:t>più</a:t>
-            </a:r>
-            <a:r>
-              <a:rPr sz="1500" b="0" dirty="0">
-                <a:solidFill>
-                  <a:srgbClr val="0F172A"/>
-                </a:solidFill>
-                <a:latin typeface="Aptos"/>
-              </a:rPr>
-              <a:t> </a:t>
-            </a:r>
-            <a:r>
-              <a:rPr sz="1500" b="0" dirty="0" err="1">
-                <a:solidFill>
-                  <a:srgbClr val="0F172A"/>
-                </a:solidFill>
-                <a:latin typeface="Aptos"/>
-              </a:rPr>
-              <a:t>vincolate</a:t>
-            </a:r>
-            <a:r>
-              <a:rPr sz="1500" b="0" dirty="0">
-                <a:solidFill>
-                  <a:srgbClr val="0F172A"/>
-                </a:solidFill>
-                <a:latin typeface="Aptos"/>
-              </a:rPr>
-              <a:t>, </a:t>
-            </a:r>
-            <a:r>
-              <a:rPr sz="1500" b="0" dirty="0" err="1">
-                <a:solidFill>
-                  <a:srgbClr val="0F172A"/>
-                </a:solidFill>
-                <a:latin typeface="Aptos"/>
-              </a:rPr>
-              <a:t>simulazione</a:t>
-            </a:r>
-            <a:r>
-              <a:rPr sz="1500" b="0" dirty="0">
-                <a:solidFill>
-                  <a:srgbClr val="0F172A"/>
-                </a:solidFill>
-                <a:latin typeface="Aptos"/>
-              </a:rPr>
-              <a:t> e datasheet.</a:t>
-            </a:r>
+              <a:rPr lang="it-IT" sz="1500" b="0" dirty="0">
+                <a:solidFill>
+                  <a:srgbClr val="0F172A"/>
+                </a:solidFill>
+                <a:latin typeface="Aptos"/>
+              </a:rPr>
+              <a:t>Possibilità di proporre scenari correttivi e controllati</a:t>
+            </a:r>
+            <a:endParaRPr sz="1500" b="0" dirty="0">
+              <a:solidFill>
+                <a:srgbClr val="0F172A"/>
+              </a:solidFill>
+              <a:latin typeface="Aptos"/>
+            </a:endParaRPr>
           </a:p>
         </p:txBody>
       </p:sp>
@@ -31034,41 +31149,6 @@
           </a:p>
         </p:txBody>
       </p:sp>
-      <p:cxnSp>
-        <p:nvCxnSpPr>
-          <p:cNvPr id="7" name="Connector 6"/>
-          <p:cNvCxnSpPr/>
-          <p:nvPr/>
-        </p:nvCxnSpPr>
-        <p:spPr>
-          <a:xfrm>
-            <a:off x="6080760" y="1874519"/>
-            <a:ext cx="0" cy="548641"/>
-          </a:xfrm>
-          <a:prstGeom prst="line">
-            <a:avLst/>
-          </a:prstGeom>
-          <a:ln w="25400">
-            <a:solidFill>
-              <a:srgbClr val="F59E0B"/>
-            </a:solidFill>
-          </a:ln>
-        </p:spPr>
-        <p:style>
-          <a:lnRef idx="2">
-            <a:schemeClr val="accent1"/>
-          </a:lnRef>
-          <a:fillRef idx="0">
-            <a:schemeClr val="accent1"/>
-          </a:fillRef>
-          <a:effectRef idx="1">
-            <a:schemeClr val="accent1"/>
-          </a:effectRef>
-          <a:fontRef idx="minor">
-            <a:schemeClr val="tx1"/>
-          </a:fontRef>
-        </p:style>
-      </p:cxnSp>
       <p:sp>
         <p:nvSpPr>
           <p:cNvPr id="8" name="Rounded Rectangle 7"/>
@@ -31317,7 +31397,7 @@
         <p:spPr>
           <a:xfrm>
             <a:off x="1051560" y="4343400"/>
-            <a:ext cx="10058400" cy="1280160"/>
+            <a:ext cx="10058400" cy="943848"/>
           </a:xfrm>
           <a:prstGeom prst="rect">
             <a:avLst/>
@@ -31514,103 +31594,13 @@
               </a:spcAft>
             </a:pPr>
             <a:r>
-              <a:rPr sz="1800" b="1" dirty="0" err="1">
+              <a:rPr lang="it-IT" b="1" dirty="0">
                 <a:solidFill>
                   <a:srgbClr val="0B1F33"/>
                 </a:solidFill>
                 <a:latin typeface="Aptos"/>
               </a:rPr>
-              <a:t>simulazione</a:t>
-            </a:r>
-            <a:r>
-              <a:rPr sz="1800" b="1" dirty="0">
-                <a:solidFill>
-                  <a:srgbClr val="0B1F33"/>
-                </a:solidFill>
-                <a:latin typeface="Aptos"/>
-              </a:rPr>
-              <a:t> completa → </a:t>
-            </a:r>
-            <a:r>
-              <a:rPr sz="1800" b="1" dirty="0" err="1">
-                <a:solidFill>
-                  <a:srgbClr val="0B1F33"/>
-                </a:solidFill>
-                <a:latin typeface="Aptos"/>
-              </a:rPr>
-              <a:t>simulazione</a:t>
-            </a:r>
-            <a:r>
-              <a:rPr sz="1800" b="1" dirty="0">
-                <a:solidFill>
-                  <a:srgbClr val="0B1F33"/>
-                </a:solidFill>
-                <a:latin typeface="Aptos"/>
-              </a:rPr>
-              <a:t> </a:t>
-            </a:r>
-            <a:r>
-              <a:rPr sz="1800" b="1" dirty="0" err="1">
-                <a:solidFill>
-                  <a:srgbClr val="0B1F33"/>
-                </a:solidFill>
-                <a:latin typeface="Aptos"/>
-              </a:rPr>
-              <a:t>semplificata</a:t>
-            </a:r>
-            <a:r>
-              <a:rPr sz="1800" b="1" dirty="0">
-                <a:solidFill>
-                  <a:srgbClr val="0B1F33"/>
-                </a:solidFill>
-                <a:latin typeface="Aptos"/>
-              </a:rPr>
-              <a:t> → </a:t>
-            </a:r>
-            <a:r>
-              <a:rPr sz="1800" b="1" dirty="0" err="1">
-                <a:solidFill>
-                  <a:srgbClr val="0B1F33"/>
-                </a:solidFill>
-                <a:latin typeface="Aptos"/>
-              </a:rPr>
-              <a:t>simulazione</a:t>
-            </a:r>
-            <a:r>
-              <a:rPr sz="1800" b="1" dirty="0">
-                <a:solidFill>
-                  <a:srgbClr val="0B1F33"/>
-                </a:solidFill>
-                <a:latin typeface="Aptos"/>
-              </a:rPr>
-              <a:t> </a:t>
-            </a:r>
-            <a:r>
-              <a:rPr sz="1800" b="1" dirty="0" err="1">
-                <a:solidFill>
-                  <a:srgbClr val="0B1F33"/>
-                </a:solidFill>
-                <a:latin typeface="Aptos"/>
-              </a:rPr>
-              <a:t>parziale</a:t>
-            </a:r>
-            <a:r>
-              <a:rPr sz="1800" b="1" dirty="0">
-                <a:solidFill>
-                  <a:srgbClr val="0B1F33"/>
-                </a:solidFill>
-                <a:latin typeface="Aptos"/>
-              </a:rPr>
-              <a:t> → solo report </a:t>
-            </a:r>
-            <a:r>
-              <a:rPr sz="1800" b="1" dirty="0" err="1">
-                <a:solidFill>
-                  <a:srgbClr val="0B1F33"/>
-                </a:solidFill>
-                <a:latin typeface="Aptos"/>
-              </a:rPr>
-              <a:t>diagnostico</a:t>
+              <a:t>simulazione completa → simulazione semplificata → simulazione parziale → contesto diagnostico senza simulazione</a:t>
             </a:r>
             <a:endParaRPr sz="1800" b="1" dirty="0">
               <a:solidFill>
@@ -34123,8 +34113,8 @@
         </p:nvSpPr>
         <p:spPr>
           <a:xfrm>
-            <a:off x="6355080" y="1143000"/>
-            <a:ext cx="5303520" cy="4526280"/>
+            <a:off x="6364224" y="1052150"/>
+            <a:ext cx="5303520" cy="5001768"/>
           </a:xfrm>
           <a:prstGeom prst="roundRect">
             <a:avLst/>
@@ -34157,7 +34147,12 @@
           <a:lstStyle/>
           <a:p>
             <a:pPr algn="ctr"/>
-            <a:endParaRPr/>
+            <a:endParaRPr lang="it-IT" b="1" dirty="0">
+              <a:solidFill>
+                <a:srgbClr val="0B1F33"/>
+              </a:solidFill>
+              <a:latin typeface="Aptos"/>
+            </a:endParaRPr>
           </a:p>
         </p:txBody>
       </p:sp>
@@ -34397,14 +34392,65 @@
           <a:p>
             <a:pPr algn="ctr"/>
             <a:r>
-              <a:rPr sz="1200" b="1" i="0" dirty="0">
+              <a:rPr lang="it-IT" sz="1200" b="1" i="0" dirty="0" err="1">
                 <a:solidFill>
                   <a:srgbClr val="0B1F33"/>
                 </a:solidFill>
                 <a:latin typeface="Aptos"/>
               </a:rPr>
-              <a:t>Node map + YAML</a:t>
-            </a:r>
+              <a:t>Normalization</a:t>
+            </a:r>
+            <a:r>
+              <a:rPr lang="it-IT" sz="1200" b="1" i="0" dirty="0">
+                <a:solidFill>
+                  <a:srgbClr val="0B1F33"/>
+                </a:solidFill>
+                <a:latin typeface="Aptos"/>
+              </a:rPr>
+              <a:t> + </a:t>
+            </a:r>
+            <a:r>
+              <a:rPr lang="it-IT" sz="1200" b="1" i="0" dirty="0" err="1">
+                <a:solidFill>
+                  <a:srgbClr val="0B1F33"/>
+                </a:solidFill>
+                <a:latin typeface="Aptos"/>
+              </a:rPr>
+              <a:t>nod</a:t>
+            </a:r>
+            <a:r>
+              <a:rPr lang="it-IT" sz="1200" b="1" dirty="0" err="1">
+                <a:solidFill>
+                  <a:srgbClr val="0B1F33"/>
+                </a:solidFill>
+                <a:latin typeface="Aptos"/>
+              </a:rPr>
+              <a:t>e</a:t>
+            </a:r>
+            <a:r>
+              <a:rPr lang="it-IT" sz="1200" b="1" dirty="0">
+                <a:solidFill>
+                  <a:srgbClr val="0B1F33"/>
+                </a:solidFill>
+                <a:latin typeface="Aptos"/>
+              </a:rPr>
+              <a:t> </a:t>
+            </a:r>
+            <a:r>
+              <a:rPr lang="it-IT" sz="1200" b="1" dirty="0" err="1">
+                <a:solidFill>
+                  <a:srgbClr val="0B1F33"/>
+                </a:solidFill>
+                <a:latin typeface="Aptos"/>
+              </a:rPr>
+              <a:t>map</a:t>
+            </a:r>
+            <a:endParaRPr sz="1200" b="1" i="0" dirty="0">
+              <a:solidFill>
+                <a:srgbClr val="0B1F33"/>
+              </a:solidFill>
+              <a:latin typeface="Aptos"/>
+            </a:endParaRPr>
           </a:p>
         </p:txBody>
       </p:sp>
@@ -34513,14 +34559,29 @@
           <a:p>
             <a:pPr algn="ctr"/>
             <a:r>
-              <a:rPr sz="1200" b="1" i="0" dirty="0">
+              <a:rPr lang="it-IT" sz="1200" b="1" i="0" dirty="0">
                 <a:solidFill>
                   <a:srgbClr val="0B1F33"/>
                 </a:solidFill>
                 <a:latin typeface="Aptos"/>
               </a:rPr>
-              <a:t>Netlist SPICE</a:t>
-            </a:r>
+              <a:t>Manual / OCR </a:t>
+            </a:r>
+            <a:r>
+              <a:rPr lang="it-IT" sz="1200" b="1" i="0" dirty="0" err="1">
+                <a:solidFill>
+                  <a:srgbClr val="0B1F33"/>
+                </a:solidFill>
+                <a:latin typeface="Aptos"/>
+              </a:rPr>
+              <a:t>values</a:t>
+            </a:r>
+            <a:endParaRPr sz="1200" b="1" i="0" dirty="0">
+              <a:solidFill>
+                <a:srgbClr val="0B1F33"/>
+              </a:solidFill>
+              <a:latin typeface="Aptos"/>
+            </a:endParaRPr>
           </a:p>
         </p:txBody>
       </p:sp>
@@ -34629,31 +34690,13 @@
           <a:p>
             <a:pPr algn="ctr"/>
             <a:r>
-              <a:rPr sz="1200" b="1" i="0" dirty="0" err="1">
+              <a:rPr lang="it-IT" sz="1200" b="1" i="0" dirty="0">
                 <a:solidFill>
                   <a:srgbClr val="0B1F33"/>
                 </a:solidFill>
                 <a:latin typeface="Aptos"/>
               </a:rPr>
-              <a:t>ngspice</a:t>
-            </a:r>
-            <a:r>
-              <a:rPr sz="1200" b="1" i="0" dirty="0">
-                <a:solidFill>
-                  <a:srgbClr val="0B1F33"/>
-                </a:solidFill>
-                <a:latin typeface="Aptos"/>
-              </a:rPr>
-              <a:t> + </a:t>
-            </a:r>
-            <a:r>
-              <a:rPr sz="1200" b="1" i="0" dirty="0" err="1">
-                <a:solidFill>
-                  <a:srgbClr val="0B1F33"/>
-                </a:solidFill>
-                <a:latin typeface="Aptos"/>
-              </a:rPr>
-              <a:t>risultati</a:t>
+              <a:t>Component rules</a:t>
             </a:r>
             <a:endParaRPr sz="1200" b="1" i="0" dirty="0">
               <a:solidFill>
@@ -34769,32 +34812,29 @@
           <a:p>
             <a:pPr algn="ctr"/>
             <a:r>
-              <a:rPr sz="1200" b="1" i="0" dirty="0">
+              <a:rPr lang="it-IT" sz="1200" b="1" i="0" dirty="0">
                 <a:solidFill>
                   <a:srgbClr val="0B1F33"/>
                 </a:solidFill>
                 <a:latin typeface="Aptos"/>
               </a:rPr>
-              <a:t>Report + </a:t>
-            </a:r>
-            <a:r>
-              <a:rPr sz="1200" b="1" i="0" dirty="0" err="1">
+              <a:t>SPICE </a:t>
+            </a:r>
+            <a:r>
+              <a:rPr lang="it-IT" sz="1200" b="1" i="0" dirty="0" err="1">
                 <a:solidFill>
                   <a:srgbClr val="0B1F33"/>
                 </a:solidFill>
                 <a:latin typeface="Aptos"/>
               </a:rPr>
-              <a:t>contesto</a:t>
-            </a:r>
-            <a:r>
-              <a:rPr sz="1200" b="1" i="0" dirty="0">
-                <a:solidFill>
-                  <a:srgbClr val="0B1F33"/>
-                </a:solidFill>
-                <a:latin typeface="Aptos"/>
-              </a:rPr>
-              <a:t> GPT</a:t>
-            </a:r>
+              <a:t>netlist</a:t>
+            </a:r>
+            <a:endParaRPr sz="1200" b="1" i="0" dirty="0">
+              <a:solidFill>
+                <a:srgbClr val="0B1F33"/>
+              </a:solidFill>
+              <a:latin typeface="Aptos"/>
+            </a:endParaRPr>
           </a:p>
         </p:txBody>
       </p:sp>
@@ -34903,23 +34943,38 @@
           <a:p>
             <a:pPr algn="ctr"/>
             <a:r>
-              <a:rPr sz="1200" b="1" i="0" dirty="0" err="1">
+              <a:rPr lang="it-IT" sz="1200" b="1" i="0" dirty="0" err="1">
                 <a:solidFill>
                   <a:srgbClr val="0B1F33"/>
                 </a:solidFill>
                 <a:latin typeface="Aptos"/>
               </a:rPr>
-              <a:t>Agente</a:t>
-            </a:r>
-            <a:r>
-              <a:rPr sz="1200" b="1" i="0" dirty="0">
+              <a:t>Ngspice</a:t>
+            </a:r>
+            <a:r>
+              <a:rPr lang="it-IT" sz="1200" b="1" i="0" dirty="0">
                 <a:solidFill>
                   <a:srgbClr val="0B1F33"/>
                 </a:solidFill>
                 <a:latin typeface="Aptos"/>
               </a:rPr>
-              <a:t> AI</a:t>
-            </a:r>
+              <a:t> </a:t>
+            </a:r>
+            <a:r>
+              <a:rPr lang="it-IT" sz="1200" b="1" i="0" dirty="0" err="1">
+                <a:solidFill>
+                  <a:srgbClr val="0B1F33"/>
+                </a:solidFill>
+                <a:latin typeface="Aptos"/>
+              </a:rPr>
+              <a:t>execution</a:t>
+            </a:r>
+            <a:endParaRPr sz="1200" b="1" i="0" dirty="0">
+              <a:solidFill>
+                <a:srgbClr val="0B1F33"/>
+              </a:solidFill>
+              <a:latin typeface="Aptos"/>
+            </a:endParaRPr>
           </a:p>
         </p:txBody>
       </p:sp>
@@ -35030,6 +35085,420 @@
                 <a:latin typeface="Aptos"/>
               </a:rPr>
               <a:t>4</a:t>
+            </a:r>
+          </a:p>
+        </p:txBody>
+      </p:sp>
+      <p:sp>
+        <p:nvSpPr>
+          <p:cNvPr id="24" name="Rounded Rectangle 40">
+            <a:extLst>
+              <a:ext uri="{FF2B5EF4-FFF2-40B4-BE49-F238E27FC236}">
+                <a16:creationId xmlns:a16="http://schemas.microsoft.com/office/drawing/2014/main" id="{FBA9CCE0-3A5C-AC4F-1AE0-BDC5B0C72B07}"/>
+              </a:ext>
+            </a:extLst>
+          </p:cNvPr>
+          <p:cNvSpPr/>
+          <p:nvPr/>
+        </p:nvSpPr>
+        <p:spPr>
+          <a:xfrm>
+            <a:off x="6882384" y="4974336"/>
+            <a:ext cx="4297680" cy="347472"/>
+          </a:xfrm>
+          <a:prstGeom prst="roundRect">
+            <a:avLst/>
+          </a:prstGeom>
+          <a:solidFill>
+            <a:srgbClr val="CCFBF1"/>
+          </a:solidFill>
+          <a:ln w="12700">
+            <a:solidFill>
+              <a:srgbClr val="0F766E"/>
+            </a:solidFill>
+          </a:ln>
+        </p:spPr>
+        <p:style>
+          <a:lnRef idx="1">
+            <a:schemeClr val="accent1"/>
+          </a:lnRef>
+          <a:fillRef idx="3">
+            <a:schemeClr val="accent1"/>
+          </a:fillRef>
+          <a:effectRef idx="2">
+            <a:schemeClr val="accent1"/>
+          </a:effectRef>
+          <a:fontRef idx="minor">
+            <a:schemeClr val="lt1"/>
+          </a:fontRef>
+        </p:style>
+        <p:txBody>
+          <a:bodyPr rtlCol="0" anchor="ctr"/>
+          <a:lstStyle/>
+          <a:p>
+            <a:pPr algn="ctr"/>
+            <a:endParaRPr/>
+          </a:p>
+        </p:txBody>
+      </p:sp>
+      <p:sp>
+        <p:nvSpPr>
+          <p:cNvPr id="46" name="TextBox 41">
+            <a:extLst>
+              <a:ext uri="{FF2B5EF4-FFF2-40B4-BE49-F238E27FC236}">
+                <a16:creationId xmlns:a16="http://schemas.microsoft.com/office/drawing/2014/main" id="{090619F5-8416-F35F-4B63-98E8E3349555}"/>
+              </a:ext>
+            </a:extLst>
+          </p:cNvPr>
+          <p:cNvSpPr txBox="1"/>
+          <p:nvPr/>
+        </p:nvSpPr>
+        <p:spPr>
+          <a:xfrm>
+            <a:off x="7046976" y="5084064"/>
+            <a:ext cx="4005072" cy="221599"/>
+          </a:xfrm>
+          <a:prstGeom prst="rect">
+            <a:avLst/>
+          </a:prstGeom>
+          <a:noFill/>
+        </p:spPr>
+        <p:txBody>
+          <a:bodyPr wrap="square" lIns="18288" tIns="18288" rIns="18288" bIns="18288" anchor="t">
+            <a:spAutoFit/>
+          </a:bodyPr>
+          <a:lstStyle/>
+          <a:p>
+            <a:pPr algn="ctr"/>
+            <a:r>
+              <a:rPr lang="it-IT" sz="1200" b="1" i="0" dirty="0">
+                <a:solidFill>
+                  <a:srgbClr val="0B1F33"/>
+                </a:solidFill>
+                <a:latin typeface="Aptos"/>
+              </a:rPr>
+              <a:t>SPICE </a:t>
+            </a:r>
+            <a:r>
+              <a:rPr lang="it-IT" sz="1200" b="1" i="0" dirty="0" err="1">
+                <a:solidFill>
+                  <a:srgbClr val="0B1F33"/>
+                </a:solidFill>
+                <a:latin typeface="Aptos"/>
+              </a:rPr>
+              <a:t>results</a:t>
+            </a:r>
+            <a:endParaRPr sz="1200" b="1" i="0" dirty="0">
+              <a:solidFill>
+                <a:srgbClr val="0B1F33"/>
+              </a:solidFill>
+              <a:latin typeface="Aptos"/>
+            </a:endParaRPr>
+          </a:p>
+        </p:txBody>
+      </p:sp>
+      <p:sp>
+        <p:nvSpPr>
+          <p:cNvPr id="47" name="Rounded Rectangle 40">
+            <a:extLst>
+              <a:ext uri="{FF2B5EF4-FFF2-40B4-BE49-F238E27FC236}">
+                <a16:creationId xmlns:a16="http://schemas.microsoft.com/office/drawing/2014/main" id="{A784CBC2-D9E0-5514-6E7E-68A12A203482}"/>
+              </a:ext>
+            </a:extLst>
+          </p:cNvPr>
+          <p:cNvSpPr/>
+          <p:nvPr/>
+        </p:nvSpPr>
+        <p:spPr>
+          <a:xfrm>
+            <a:off x="6900672" y="5522976"/>
+            <a:ext cx="4297680" cy="347472"/>
+          </a:xfrm>
+          <a:prstGeom prst="roundRect">
+            <a:avLst/>
+          </a:prstGeom>
+          <a:solidFill>
+            <a:srgbClr val="CCFBF1"/>
+          </a:solidFill>
+          <a:ln w="12700">
+            <a:solidFill>
+              <a:srgbClr val="0F766E"/>
+            </a:solidFill>
+          </a:ln>
+        </p:spPr>
+        <p:style>
+          <a:lnRef idx="1">
+            <a:schemeClr val="accent1"/>
+          </a:lnRef>
+          <a:fillRef idx="3">
+            <a:schemeClr val="accent1"/>
+          </a:fillRef>
+          <a:effectRef idx="2">
+            <a:schemeClr val="accent1"/>
+          </a:effectRef>
+          <a:fontRef idx="minor">
+            <a:schemeClr val="lt1"/>
+          </a:fontRef>
+        </p:style>
+        <p:txBody>
+          <a:bodyPr rtlCol="0" anchor="ctr"/>
+          <a:lstStyle/>
+          <a:p>
+            <a:pPr algn="ctr"/>
+            <a:endParaRPr/>
+          </a:p>
+        </p:txBody>
+      </p:sp>
+      <p:sp>
+        <p:nvSpPr>
+          <p:cNvPr id="48" name="TextBox 41">
+            <a:extLst>
+              <a:ext uri="{FF2B5EF4-FFF2-40B4-BE49-F238E27FC236}">
+                <a16:creationId xmlns:a16="http://schemas.microsoft.com/office/drawing/2014/main" id="{9BE9B003-7382-5F65-CBE5-3D4D477D5CB3}"/>
+              </a:ext>
+            </a:extLst>
+          </p:cNvPr>
+          <p:cNvSpPr txBox="1"/>
+          <p:nvPr/>
+        </p:nvSpPr>
+        <p:spPr>
+          <a:xfrm>
+            <a:off x="7065264" y="5632704"/>
+            <a:ext cx="4005072" cy="221599"/>
+          </a:xfrm>
+          <a:prstGeom prst="rect">
+            <a:avLst/>
+          </a:prstGeom>
+          <a:noFill/>
+        </p:spPr>
+        <p:txBody>
+          <a:bodyPr wrap="square" lIns="18288" tIns="18288" rIns="18288" bIns="18288" anchor="t">
+            <a:spAutoFit/>
+          </a:bodyPr>
+          <a:lstStyle/>
+          <a:p>
+            <a:pPr algn="ctr"/>
+            <a:r>
+              <a:rPr lang="it-IT" sz="1200" b="1" i="0" dirty="0">
+                <a:solidFill>
+                  <a:srgbClr val="0B1F33"/>
+                </a:solidFill>
+                <a:latin typeface="Aptos"/>
+              </a:rPr>
+              <a:t>AI </a:t>
+            </a:r>
+            <a:r>
+              <a:rPr lang="it-IT" sz="1200" b="1" i="0" dirty="0" err="1">
+                <a:solidFill>
+                  <a:srgbClr val="0B1F33"/>
+                </a:solidFill>
+                <a:latin typeface="Aptos"/>
+              </a:rPr>
+              <a:t>diagnostic</a:t>
+            </a:r>
+            <a:r>
+              <a:rPr lang="it-IT" sz="1200" b="1" i="0" dirty="0">
+                <a:solidFill>
+                  <a:srgbClr val="0B1F33"/>
+                </a:solidFill>
+                <a:latin typeface="Aptos"/>
+              </a:rPr>
+              <a:t> agent</a:t>
+            </a:r>
+            <a:endParaRPr sz="1200" b="1" i="0" dirty="0">
+              <a:solidFill>
+                <a:srgbClr val="0B1F33"/>
+              </a:solidFill>
+              <a:latin typeface="Aptos"/>
+            </a:endParaRPr>
+          </a:p>
+        </p:txBody>
+      </p:sp>
+      <p:cxnSp>
+        <p:nvCxnSpPr>
+          <p:cNvPr id="52" name="Connector 39">
+            <a:extLst>
+              <a:ext uri="{FF2B5EF4-FFF2-40B4-BE49-F238E27FC236}">
+                <a16:creationId xmlns:a16="http://schemas.microsoft.com/office/drawing/2014/main" id="{6E2E8B39-2DB4-D265-7C91-F530D2E5FC1D}"/>
+              </a:ext>
+            </a:extLst>
+          </p:cNvPr>
+          <p:cNvCxnSpPr/>
+          <p:nvPr/>
+        </p:nvCxnSpPr>
+        <p:spPr>
+          <a:xfrm>
+            <a:off x="9025128" y="4800600"/>
+            <a:ext cx="0" cy="173736"/>
+          </a:xfrm>
+          <a:prstGeom prst="line">
+            <a:avLst/>
+          </a:prstGeom>
+          <a:ln w="19050">
+            <a:solidFill>
+              <a:srgbClr val="0F766E"/>
+            </a:solidFill>
+          </a:ln>
+        </p:spPr>
+        <p:style>
+          <a:lnRef idx="2">
+            <a:schemeClr val="accent1"/>
+          </a:lnRef>
+          <a:fillRef idx="0">
+            <a:schemeClr val="accent1"/>
+          </a:fillRef>
+          <a:effectRef idx="1">
+            <a:schemeClr val="accent1"/>
+          </a:effectRef>
+          <a:fontRef idx="minor">
+            <a:schemeClr val="tx1"/>
+          </a:fontRef>
+        </p:style>
+      </p:cxnSp>
+      <p:cxnSp>
+        <p:nvCxnSpPr>
+          <p:cNvPr id="53" name="Connector 39">
+            <a:extLst>
+              <a:ext uri="{FF2B5EF4-FFF2-40B4-BE49-F238E27FC236}">
+                <a16:creationId xmlns:a16="http://schemas.microsoft.com/office/drawing/2014/main" id="{3CB020CD-0945-C962-7FBA-7CB50E2603F7}"/>
+              </a:ext>
+            </a:extLst>
+          </p:cNvPr>
+          <p:cNvCxnSpPr/>
+          <p:nvPr/>
+        </p:nvCxnSpPr>
+        <p:spPr>
+          <a:xfrm>
+            <a:off x="9069471" y="5321808"/>
+            <a:ext cx="0" cy="173736"/>
+          </a:xfrm>
+          <a:prstGeom prst="line">
+            <a:avLst/>
+          </a:prstGeom>
+          <a:ln w="19050">
+            <a:solidFill>
+              <a:srgbClr val="0F766E"/>
+            </a:solidFill>
+          </a:ln>
+        </p:spPr>
+        <p:style>
+          <a:lnRef idx="2">
+            <a:schemeClr val="accent1"/>
+          </a:lnRef>
+          <a:fillRef idx="0">
+            <a:schemeClr val="accent1"/>
+          </a:fillRef>
+          <a:effectRef idx="1">
+            <a:schemeClr val="accent1"/>
+          </a:effectRef>
+          <a:fontRef idx="minor">
+            <a:schemeClr val="tx1"/>
+          </a:fontRef>
+        </p:style>
+      </p:cxnSp>
+      <p:sp>
+        <p:nvSpPr>
+          <p:cNvPr id="55" name="CasellaDiTesto 54">
+            <a:extLst>
+              <a:ext uri="{FF2B5EF4-FFF2-40B4-BE49-F238E27FC236}">
+                <a16:creationId xmlns:a16="http://schemas.microsoft.com/office/drawing/2014/main" id="{CFDD7092-7BAC-597C-F32A-536D18B197B7}"/>
+              </a:ext>
+            </a:extLst>
+          </p:cNvPr>
+          <p:cNvSpPr txBox="1"/>
+          <p:nvPr/>
+        </p:nvSpPr>
+        <p:spPr>
+          <a:xfrm>
+            <a:off x="6095847" y="6128082"/>
+            <a:ext cx="6150076" cy="461665"/>
+          </a:xfrm>
+          <a:prstGeom prst="rect">
+            <a:avLst/>
+          </a:prstGeom>
+          <a:noFill/>
+        </p:spPr>
+        <p:txBody>
+          <a:bodyPr wrap="square">
+            <a:spAutoFit/>
+          </a:bodyPr>
+          <a:lstStyle/>
+          <a:p>
+            <a:r>
+              <a:rPr lang="it-IT" sz="1200" dirty="0"/>
+              <a:t>The agent </a:t>
+            </a:r>
+            <a:r>
+              <a:rPr lang="it-IT" sz="1200" dirty="0" err="1"/>
+              <a:t>is</a:t>
+            </a:r>
+            <a:r>
+              <a:rPr lang="it-IT" sz="1200" dirty="0"/>
+              <a:t> </a:t>
+            </a:r>
+            <a:r>
+              <a:rPr lang="it-IT" sz="1200" dirty="0" err="1"/>
+              <a:t>activated</a:t>
+            </a:r>
+            <a:r>
+              <a:rPr lang="it-IT" sz="1200" dirty="0"/>
+              <a:t> after SPICE </a:t>
+            </a:r>
+            <a:r>
+              <a:rPr lang="it-IT" sz="1200" dirty="0" err="1"/>
+              <a:t>execution</a:t>
+            </a:r>
+            <a:r>
+              <a:rPr lang="it-IT" sz="1200" dirty="0"/>
+              <a:t> and </a:t>
+            </a:r>
+            <a:r>
+              <a:rPr lang="it-IT" sz="1200" dirty="0" err="1"/>
+              <a:t>receives</a:t>
+            </a:r>
+            <a:r>
+              <a:rPr lang="it-IT" sz="1200" dirty="0"/>
+              <a:t> the </a:t>
+            </a:r>
+            <a:r>
+              <a:rPr lang="it-IT" sz="1200" dirty="0" err="1"/>
+              <a:t>circuit</a:t>
+            </a:r>
+            <a:r>
+              <a:rPr lang="it-IT" sz="1200" dirty="0"/>
+              <a:t> </a:t>
+            </a:r>
+            <a:r>
+              <a:rPr lang="it-IT" sz="1200" dirty="0" err="1"/>
+              <a:t>problem</a:t>
+            </a:r>
+            <a:r>
+              <a:rPr lang="it-IT" sz="1200" dirty="0"/>
+              <a:t>, </a:t>
+            </a:r>
+            <a:r>
+              <a:rPr lang="it-IT" sz="1200" dirty="0" err="1"/>
+              <a:t>graph</a:t>
+            </a:r>
+            <a:r>
+              <a:rPr lang="it-IT" sz="1200" dirty="0"/>
+              <a:t> data, </a:t>
+            </a:r>
+            <a:r>
+              <a:rPr lang="it-IT" sz="1200" dirty="0" err="1"/>
+              <a:t>netlist</a:t>
+            </a:r>
+            <a:r>
+              <a:rPr lang="it-IT" sz="1200" dirty="0"/>
+              <a:t> and </a:t>
+            </a:r>
+            <a:r>
+              <a:rPr lang="it-IT" sz="1200" dirty="0" err="1"/>
+              <a:t>ngspice</a:t>
+            </a:r>
+            <a:r>
+              <a:rPr lang="it-IT" sz="1200" dirty="0"/>
+              <a:t> output.</a:t>
             </a:r>
           </a:p>
         </p:txBody>
@@ -35980,7 +36449,7 @@
         <p:spPr>
           <a:xfrm>
             <a:off x="8439912" y="1600200"/>
-            <a:ext cx="2907792" cy="2298065"/>
+            <a:ext cx="2907792" cy="3211135"/>
           </a:xfrm>
           <a:prstGeom prst="rect">
             <a:avLst/>
@@ -36065,6 +36534,33 @@
               </a:rPr>
               <a:t>valori</a:t>
             </a:r>
+            <a:r>
+              <a:rPr lang="it-IT" sz="1500" b="1" dirty="0">
+                <a:solidFill>
+                  <a:srgbClr val="0F172A"/>
+                </a:solidFill>
+                <a:latin typeface="Aptos"/>
+              </a:rPr>
+              <a:t> </a:t>
+            </a:r>
+            <a:r>
+              <a:rPr lang="it-IT" sz="1500" dirty="0">
+                <a:solidFill>
+                  <a:srgbClr val="0F172A"/>
+                </a:solidFill>
+                <a:latin typeface="Aptos"/>
+              </a:rPr>
+              <a:t>e </a:t>
+            </a:r>
+            <a:r>
+              <a:rPr lang="it-IT" sz="1500" b="1" dirty="0">
+                <a:solidFill>
+                  <a:srgbClr val="0F172A"/>
+                </a:solidFill>
+                <a:latin typeface="Aptos"/>
+              </a:rPr>
+              <a:t>modelli</a:t>
+            </a:r>
             <a:endParaRPr sz="1500" b="1" dirty="0">
               <a:solidFill>
                 <a:srgbClr val="0F172A"/>
@@ -36086,71 +36582,42 @@
             </a:endParaRPr>
           </a:p>
           <a:p>
-            <a:pPr>
-              <a:spcAft>
-                <a:spcPts val="400"/>
-              </a:spcAft>
-            </a:pPr>
-            <a:r>
-              <a:rPr sz="1500" b="0" dirty="0">
-                <a:solidFill>
-                  <a:srgbClr val="0F172A"/>
-                </a:solidFill>
-                <a:latin typeface="Aptos"/>
-              </a:rPr>
-              <a:t>GPT </a:t>
-            </a:r>
-            <a:r>
-              <a:rPr sz="1500" b="0" dirty="0" err="1">
-                <a:solidFill>
-                  <a:srgbClr val="0F172A"/>
-                </a:solidFill>
-                <a:latin typeface="Aptos"/>
-              </a:rPr>
-              <a:t>usa</a:t>
-            </a:r>
-            <a:r>
-              <a:rPr sz="1500" b="0" dirty="0">
-                <a:solidFill>
-                  <a:srgbClr val="0F172A"/>
-                </a:solidFill>
-                <a:latin typeface="Aptos"/>
-              </a:rPr>
-              <a:t> </a:t>
-            </a:r>
-            <a:r>
-              <a:rPr sz="1500" b="1" dirty="0" err="1">
-                <a:solidFill>
-                  <a:srgbClr val="0F172A"/>
-                </a:solidFill>
-                <a:latin typeface="Aptos"/>
-              </a:rPr>
-              <a:t>evidenze</a:t>
-            </a:r>
-            <a:r>
-              <a:rPr sz="1500" b="1" dirty="0">
-                <a:solidFill>
-                  <a:srgbClr val="0F172A"/>
-                </a:solidFill>
-                <a:latin typeface="Aptos"/>
-              </a:rPr>
-              <a:t> </a:t>
-            </a:r>
-            <a:r>
-              <a:rPr sz="1500" b="1" dirty="0" err="1">
-                <a:solidFill>
-                  <a:srgbClr val="0F172A"/>
-                </a:solidFill>
-                <a:latin typeface="Aptos"/>
-              </a:rPr>
-              <a:t>organizzate</a:t>
-            </a:r>
-            <a:endParaRPr sz="1500" b="1" dirty="0">
-              <a:solidFill>
-                <a:srgbClr val="0F172A"/>
-              </a:solidFill>
-              <a:latin typeface="Aptos"/>
-            </a:endParaRPr>
+            <a:r>
+              <a:rPr lang="it-IT" sz="1500" dirty="0" err="1">
+                <a:latin typeface="Aptos" panose="020B0004020202020204" pitchFamily="34" charset="0"/>
+              </a:rPr>
+              <a:t>ngspice</a:t>
+            </a:r>
+            <a:r>
+              <a:rPr lang="it-IT" sz="1500" dirty="0">
+                <a:latin typeface="Aptos" panose="020B0004020202020204" pitchFamily="34" charset="0"/>
+              </a:rPr>
+              <a:t> produce </a:t>
+            </a:r>
+            <a:r>
+              <a:rPr lang="it-IT" sz="1500" dirty="0" err="1">
+                <a:latin typeface="Aptos" panose="020B0004020202020204" pitchFamily="34" charset="0"/>
+              </a:rPr>
+              <a:t>stdout</a:t>
+            </a:r>
+            <a:r>
+              <a:rPr lang="it-IT" sz="1500" dirty="0">
+                <a:latin typeface="Aptos" panose="020B0004020202020204" pitchFamily="34" charset="0"/>
+              </a:rPr>
+              <a:t>/</a:t>
+            </a:r>
+            <a:r>
+              <a:rPr lang="it-IT" sz="1500" dirty="0" err="1">
+                <a:latin typeface="Aptos" panose="020B0004020202020204" pitchFamily="34" charset="0"/>
+              </a:rPr>
+              <a:t>stderr</a:t>
+            </a:r>
+            <a:r>
+              <a:rPr lang="it-IT" sz="1500" dirty="0">
+                <a:latin typeface="Aptos" panose="020B0004020202020204" pitchFamily="34" charset="0"/>
+              </a:rPr>
+              <a:t> e risultati numerici</a:t>
+            </a:r>
           </a:p>
           <a:p>
             <a:pPr>
@@ -36166,71 +36633,12 @@
             </a:endParaRPr>
           </a:p>
           <a:p>
-            <a:pPr>
-              <a:spcAft>
-                <a:spcPts val="400"/>
-              </a:spcAft>
-            </a:pPr>
-            <a:r>
-              <a:rPr sz="1500" b="0" dirty="0">
-                <a:solidFill>
-                  <a:srgbClr val="0F172A"/>
-                </a:solidFill>
-                <a:latin typeface="Aptos"/>
-              </a:rPr>
-              <a:t>Report </a:t>
-            </a:r>
-            <a:r>
-              <a:rPr sz="1500" b="0" dirty="0" err="1">
-                <a:solidFill>
-                  <a:srgbClr val="0F172A"/>
-                </a:solidFill>
-                <a:latin typeface="Aptos"/>
-              </a:rPr>
-              <a:t>confrontabile</a:t>
-            </a:r>
-            <a:r>
-              <a:rPr sz="1500" b="0" dirty="0">
-                <a:solidFill>
-                  <a:srgbClr val="0F172A"/>
-                </a:solidFill>
-                <a:latin typeface="Aptos"/>
-              </a:rPr>
-              <a:t> </a:t>
-            </a:r>
-            <a:r>
-              <a:rPr sz="1500" b="0" dirty="0" err="1">
-                <a:solidFill>
-                  <a:srgbClr val="0F172A"/>
-                </a:solidFill>
-                <a:latin typeface="Aptos"/>
-              </a:rPr>
-              <a:t>tra</a:t>
-            </a:r>
-            <a:r>
-              <a:rPr sz="1500" b="0" dirty="0">
-                <a:solidFill>
-                  <a:srgbClr val="0F172A"/>
-                </a:solidFill>
-                <a:latin typeface="Aptos"/>
-              </a:rPr>
-              <a:t> </a:t>
-            </a:r>
-            <a:r>
-              <a:rPr sz="1500" b="0" dirty="0" err="1">
-                <a:solidFill>
-                  <a:srgbClr val="0F172A"/>
-                </a:solidFill>
-                <a:latin typeface="Aptos"/>
-              </a:rPr>
-              <a:t>circuiti</a:t>
-            </a:r>
-            <a:endParaRPr sz="1500" b="0" dirty="0">
-              <a:solidFill>
-                <a:srgbClr val="0F172A"/>
-              </a:solidFill>
-              <a:latin typeface="Aptos"/>
-            </a:endParaRPr>
+            <a:r>
+              <a:rPr lang="it-IT" sz="1500" dirty="0">
+                <a:latin typeface="Aptos" panose="020B0004020202020204" pitchFamily="34" charset="0"/>
+              </a:rPr>
+              <a:t>GPT riceve evidenze strutturate dopo la simulazione</a:t>
+            </a:r>
           </a:p>
           <a:p>
             <a:pPr>
@@ -36246,62 +36654,12 @@
             </a:endParaRPr>
           </a:p>
           <a:p>
-            <a:pPr>
-              <a:spcAft>
-                <a:spcPts val="400"/>
-              </a:spcAft>
-            </a:pPr>
-            <a:r>
-              <a:rPr sz="1500" b="0" dirty="0" err="1">
-                <a:solidFill>
-                  <a:srgbClr val="0F172A"/>
-                </a:solidFill>
-                <a:latin typeface="Aptos"/>
-              </a:rPr>
-              <a:t>Diagnosi</a:t>
-            </a:r>
-            <a:r>
-              <a:rPr sz="1500" b="0" dirty="0">
-                <a:solidFill>
-                  <a:srgbClr val="0F172A"/>
-                </a:solidFill>
-                <a:latin typeface="Aptos"/>
-              </a:rPr>
-              <a:t> </a:t>
-            </a:r>
-            <a:r>
-              <a:rPr sz="1500" b="0" dirty="0" err="1">
-                <a:solidFill>
-                  <a:srgbClr val="0F172A"/>
-                </a:solidFill>
-                <a:latin typeface="Aptos"/>
-              </a:rPr>
-              <a:t>più</a:t>
-            </a:r>
-            <a:r>
-              <a:rPr sz="1500" b="0" dirty="0">
-                <a:solidFill>
-                  <a:srgbClr val="0F172A"/>
-                </a:solidFill>
-                <a:latin typeface="Aptos"/>
-              </a:rPr>
-              <a:t> </a:t>
-            </a:r>
-            <a:r>
-              <a:rPr sz="1500" b="0" dirty="0" err="1">
-                <a:solidFill>
-                  <a:srgbClr val="0F172A"/>
-                </a:solidFill>
-                <a:latin typeface="Aptos"/>
-              </a:rPr>
-              <a:t>controllata</a:t>
-            </a:r>
-            <a:endParaRPr sz="1500" b="0" dirty="0">
-              <a:solidFill>
-                <a:srgbClr val="0F172A"/>
-              </a:solidFill>
-              <a:latin typeface="Aptos"/>
-            </a:endParaRPr>
+            <a:r>
+              <a:rPr lang="it-IT" sz="1500" dirty="0">
+                <a:latin typeface="Aptos" panose="020B0004020202020204" pitchFamily="34" charset="0"/>
+              </a:rPr>
+              <a:t>Diagnosi più controllata e confrontabile</a:t>
+            </a:r>
           </a:p>
         </p:txBody>
       </p:sp>
@@ -36555,7 +36913,7 @@
         <p:spPr>
           <a:xfrm>
             <a:off x="475488" y="713232"/>
-            <a:ext cx="9784080" cy="320040"/>
+            <a:ext cx="9784080" cy="284693"/>
           </a:xfrm>
           <a:prstGeom prst="rect">
             <a:avLst/>
@@ -36570,14 +36928,29 @@
           <a:p>
             <a:pPr algn="l"/>
             <a:r>
-              <a:rPr sz="1250" b="0" i="0">
+              <a:rPr sz="1250" b="0" i="0" dirty="0">
                 <a:solidFill>
                   <a:srgbClr val="0F766E"/>
                 </a:solidFill>
                 <a:latin typeface="Aptos"/>
               </a:rPr>
-              <a:t>Il JSON non basta: viene completato in modo tracciabile</a:t>
-            </a:r>
+              <a:t>Il JSON </a:t>
+            </a:r>
+            <a:r>
+              <a:rPr lang="it-IT" sz="1250" b="0" i="0" dirty="0">
+                <a:solidFill>
+                  <a:srgbClr val="0F766E"/>
+                </a:solidFill>
+                <a:latin typeface="Aptos"/>
+              </a:rPr>
+              <a:t>è il punto di partenza, ma viene arricchito con valori, profili e conoscenza elettrica</a:t>
+            </a:r>
+            <a:endParaRPr sz="1250" b="0" i="0" dirty="0">
+              <a:solidFill>
+                <a:srgbClr val="0F766E"/>
+              </a:solidFill>
+              <a:latin typeface="Aptos"/>
+            </a:endParaRPr>
           </a:p>
         </p:txBody>
       </p:sp>
@@ -39892,13 +40265,31 @@
           <a:p>
             <a:pPr algn="l"/>
             <a:r>
+              <a:rPr lang="it-IT" sz="1500" b="1" i="0" dirty="0" err="1">
+                <a:solidFill>
+                  <a:srgbClr val="2563EB"/>
+                </a:solidFill>
+                <a:latin typeface="Aptos"/>
+              </a:rPr>
+              <a:t>Values_bound</a:t>
+            </a:r>
+            <a:r>
+              <a:rPr sz="1500" b="1" i="0" dirty="0">
+                <a:solidFill>
+                  <a:srgbClr val="2563EB"/>
+                </a:solidFill>
+                <a:latin typeface="Aptos"/>
+              </a:rPr>
+              <a:t>.</a:t>
+            </a:r>
+            <a:r>
               <a:rPr sz="1500" b="1" i="0" dirty="0" err="1">
                 <a:solidFill>
                   <a:srgbClr val="2563EB"/>
                 </a:solidFill>
                 <a:latin typeface="Aptos"/>
               </a:rPr>
-              <a:t>conversion_report.json</a:t>
+              <a:t>json</a:t>
             </a:r>
             <a:endParaRPr sz="1500" b="1" i="0" dirty="0">
               <a:solidFill>
@@ -40882,31 +41273,22 @@
           <a:p>
             <a:pPr algn="l"/>
             <a:r>
-              <a:rPr sz="1500" b="1" i="0" dirty="0" err="1">
+              <a:rPr lang="it-IT" sz="1500" b="1" dirty="0">
                 <a:solidFill>
                   <a:srgbClr val="64748B"/>
                 </a:solidFill>
                 <a:latin typeface="Aptos"/>
               </a:rPr>
-              <a:t>circuit_graph.svg</a:t>
-            </a:r>
-            <a:r>
-              <a:rPr sz="1500" b="1" i="0" dirty="0">
+              <a:t>r</a:t>
+            </a:r>
+            <a:r>
+              <a:rPr lang="it-IT" sz="1500" b="1" i="0" dirty="0">
                 <a:solidFill>
                   <a:srgbClr val="64748B"/>
                 </a:solidFill>
                 <a:latin typeface="Aptos"/>
               </a:rPr>
-              <a:t>/</a:t>
-            </a:r>
-            <a:r>
-              <a:rPr sz="1500" b="1" i="0" dirty="0" err="1">
-                <a:solidFill>
-                  <a:srgbClr val="64748B"/>
-                </a:solidFill>
-                <a:latin typeface="Aptos"/>
-              </a:rPr>
-              <a:t>png</a:t>
+              <a:t>eport.md</a:t>
             </a:r>
             <a:endParaRPr sz="1500" b="1" i="0" dirty="0">
               <a:solidFill>
@@ -41092,14 +41474,29 @@
           <a:p>
             <a:pPr algn="l"/>
             <a:r>
-              <a:rPr sz="1500" b="1" i="0" dirty="0">
+              <a:rPr lang="it-IT" sz="1500" b="1" dirty="0" err="1">
                 <a:solidFill>
                   <a:srgbClr val="0F766E"/>
                 </a:solidFill>
                 <a:latin typeface="Aptos"/>
               </a:rPr>
-              <a:t>prompt_arricchito.txt</a:t>
-            </a:r>
+              <a:t>d</a:t>
+            </a:r>
+            <a:r>
+              <a:rPr lang="it-IT" sz="1500" b="1" i="0" dirty="0" err="1">
+                <a:solidFill>
+                  <a:srgbClr val="0F766E"/>
+                </a:solidFill>
+                <a:latin typeface="Aptos"/>
+              </a:rPr>
+              <a:t>iagnostic_context.json</a:t>
+            </a:r>
+            <a:endParaRPr sz="1500" b="1" i="0" dirty="0">
+              <a:solidFill>
+                <a:srgbClr val="0F766E"/>
+              </a:solidFill>
+              <a:latin typeface="Aptos"/>
+            </a:endParaRPr>
           </a:p>
         </p:txBody>
       </p:sp>
@@ -41278,14 +41675,29 @@
           <a:p>
             <a:pPr algn="l"/>
             <a:r>
-              <a:rPr sz="1500" b="1" i="0" dirty="0">
+              <a:rPr lang="it-IT" sz="1500" b="1" dirty="0" err="1">
                 <a:solidFill>
                   <a:srgbClr val="2563EB"/>
                 </a:solidFill>
                 <a:latin typeface="Aptos"/>
               </a:rPr>
-              <a:t>diagnosi_gpt.txt</a:t>
-            </a:r>
+              <a:t>a</a:t>
+            </a:r>
+            <a:r>
+              <a:rPr lang="it-IT" sz="1500" b="1" i="0" dirty="0" err="1">
+                <a:solidFill>
+                  <a:srgbClr val="2563EB"/>
+                </a:solidFill>
+                <a:latin typeface="Aptos"/>
+              </a:rPr>
+              <a:t>gent_response.json</a:t>
+            </a:r>
+            <a:endParaRPr sz="1500" b="1" i="0" dirty="0">
+              <a:solidFill>
+                <a:srgbClr val="2563EB"/>
+              </a:solidFill>
+              <a:latin typeface="Aptos"/>
+            </a:endParaRPr>
           </a:p>
         </p:txBody>
       </p:sp>
@@ -42430,7 +42842,7 @@
         <p:spPr>
           <a:xfrm>
             <a:off x="896112" y="4786813"/>
-            <a:ext cx="10241280" cy="548640"/>
+            <a:ext cx="10241280" cy="646331"/>
           </a:xfrm>
           <a:prstGeom prst="rect">
             <a:avLst/>
@@ -42460,124 +42872,16 @@
                 </a:solidFill>
                 <a:latin typeface="Aptos"/>
               </a:rPr>
-              <a:t>: ogni </a:t>
-            </a:r>
-            <a:r>
-              <a:rPr sz="1800" b="1" i="0" dirty="0" err="1">
+              <a:t>: </a:t>
+            </a:r>
+            <a:r>
+              <a:rPr lang="it-IT" b="1" dirty="0">
                 <a:solidFill>
                   <a:srgbClr val="0B1F33"/>
                 </a:solidFill>
                 <a:latin typeface="Aptos"/>
               </a:rPr>
-              <a:t>circuito</a:t>
-            </a:r>
-            <a:r>
-              <a:rPr sz="1800" b="1" i="0" dirty="0">
-                <a:solidFill>
-                  <a:srgbClr val="0B1F33"/>
-                </a:solidFill>
-                <a:latin typeface="Aptos"/>
-              </a:rPr>
-              <a:t> </a:t>
-            </a:r>
-            <a:r>
-              <a:rPr sz="1800" b="1" i="0" dirty="0" err="1">
-                <a:solidFill>
-                  <a:srgbClr val="0B1F33"/>
-                </a:solidFill>
-                <a:latin typeface="Aptos"/>
-              </a:rPr>
-              <a:t>attraversa</a:t>
-            </a:r>
-            <a:r>
-              <a:rPr sz="1800" b="1" i="0" dirty="0">
-                <a:solidFill>
-                  <a:srgbClr val="0B1F33"/>
-                </a:solidFill>
-                <a:latin typeface="Aptos"/>
-              </a:rPr>
-              <a:t> la </a:t>
-            </a:r>
-            <a:r>
-              <a:rPr sz="1800" b="1" i="0" dirty="0" err="1">
-                <a:solidFill>
-                  <a:srgbClr val="0B1F33"/>
-                </a:solidFill>
-                <a:latin typeface="Aptos"/>
-              </a:rPr>
-              <a:t>stessa</a:t>
-            </a:r>
-            <a:r>
-              <a:rPr sz="1800" b="1" i="0" dirty="0">
-                <a:solidFill>
-                  <a:srgbClr val="0B1F33"/>
-                </a:solidFill>
-                <a:latin typeface="Aptos"/>
-              </a:rPr>
-              <a:t> pipeline e produce il </a:t>
-            </a:r>
-            <a:r>
-              <a:rPr sz="1800" b="1" i="0" dirty="0" err="1">
-                <a:solidFill>
-                  <a:srgbClr val="0B1F33"/>
-                </a:solidFill>
-                <a:latin typeface="Aptos"/>
-              </a:rPr>
-              <a:t>massimo</a:t>
-            </a:r>
-            <a:r>
-              <a:rPr sz="1800" b="1" i="0" dirty="0">
-                <a:solidFill>
-                  <a:srgbClr val="0B1F33"/>
-                </a:solidFill>
-                <a:latin typeface="Aptos"/>
-              </a:rPr>
-              <a:t> </a:t>
-            </a:r>
-            <a:r>
-              <a:rPr sz="1800" b="1" i="0" dirty="0" err="1">
-                <a:solidFill>
-                  <a:srgbClr val="0B1F33"/>
-                </a:solidFill>
-                <a:latin typeface="Aptos"/>
-              </a:rPr>
-              <a:t>livello</a:t>
-            </a:r>
-            <a:r>
-              <a:rPr sz="1800" b="1" i="0" dirty="0">
-                <a:solidFill>
-                  <a:srgbClr val="0B1F33"/>
-                </a:solidFill>
-                <a:latin typeface="Aptos"/>
-              </a:rPr>
-              <a:t> </a:t>
-            </a:r>
-            <a:r>
-              <a:rPr sz="1800" b="1" i="0" dirty="0" err="1">
-                <a:solidFill>
-                  <a:srgbClr val="0B1F33"/>
-                </a:solidFill>
-                <a:latin typeface="Aptos"/>
-              </a:rPr>
-              <a:t>possibile</a:t>
-            </a:r>
-            <a:r>
-              <a:rPr sz="1800" b="1" i="0" dirty="0">
-                <a:solidFill>
-                  <a:srgbClr val="0B1F33"/>
-                </a:solidFill>
-                <a:latin typeface="Aptos"/>
-              </a:rPr>
-              <a:t> di </a:t>
-            </a:r>
-            <a:r>
-              <a:rPr sz="1800" b="1" i="0" dirty="0" err="1">
-                <a:solidFill>
-                  <a:srgbClr val="0B1F33"/>
-                </a:solidFill>
-                <a:latin typeface="Aptos"/>
-              </a:rPr>
-              <a:t>analisi</a:t>
+              <a:t>Tutti i circuiti attraversano la stessa pipeline, ma non tutti raggiungono lo stesso livello di simulazione</a:t>
             </a:r>
             <a:r>
               <a:rPr sz="1800" b="1" i="0" dirty="0">

</xml_diff>